<commit_message>
Präsentation: Workflow-Folie ergänzt, IHK-Punktzahlen entfernt; Workflow umbenannt (Verordnungcheck_gemerged)
Co-Authored-By: Claude Sonnet 5.5 <noreply@anthropic.com>
Claude-Session: https://claude.ai/code/session_01Fiy9oFcgEmSsPPtPA47rVp
</commit_message>
<xml_diff>
--- a/docs/praesentation/Verordnungs-Check_IHK_3x15min_2026-10-27.pptx
+++ b/docs/praesentation/Verordnungs-Check_IHK_3x15min_2026-10-27.pptx
@@ -26,6 +26,7 @@
     <p:sldId id="274" r:id="rId20"/>
     <p:sldId id="275" r:id="rId21"/>
     <p:sldId id="276" r:id="rId22"/>
+    <p:sldId id="288" r:id="rId39"/>
     <p:sldId id="277" r:id="rId23"/>
     <p:sldId id="278" r:id="rId24"/>
     <p:sldId id="279" r:id="rId25"/>
@@ -1119,7 +1120,7 @@
           <a:p>
             <a:r>
               <a:rPr lang="en-US" dirty="0"/>
-              <a:t>VALENTIN · ca. 1 min (IHK: Tool-Vergleich, 10 Punkte).
+              <a:t>VALENTIN · ca. 1 min (IHK: Tool-Vergleich).
 Wir sind schrittweise vorgegangen, wie es der IHK-Leitfaden verlangt: Anforderungen, Kriterien, Vorauswahl, Praxistest, Fazit.
 Jede Anforderung kommt aus Thomas' Ist/Soll und ist einem der fünf IHK-Kriterien zugeordnet. Auf den nächsten Folien vergleichen wir dort, wo wir wirklich entschieden haben: Orchestrierung, Sprachmodell, Wissensbasis, Eingabekanal.</a:t>
             </a:r>
@@ -2673,7 +2674,7 @@
           <a:p>
             <a:r>
               <a:rPr lang="en-US" dirty="0"/>
-              <a:t>DERK · ca. 1,5 min (IHK: Erfolgsmessung, 10 Punkte).
+              <a:t>DERK · ca. 1,5 min (IHK: Erfolgsmessung).
 Zielwert: mindestens 98 % richtige Ampeln auf mindestens 50 neuen Fällen, jeder Fall dreimal. Höchstens ein Fehler.
 Die harten Bedingungen: kein übersehener roter Fall, höchstens ein kritischer Fehlalarm. Begründung: Ein übersehener Fehler kostet Geld, zu viele Fehlalarme zerstören das Vertrauen.
 Referenzstandard sind ausschließlich die Regelwerke, nicht die Meinung des Teams.</a:t>
@@ -2856,7 +2857,7 @@
           <a:p>
             <a:r>
               <a:rPr lang="en-US" dirty="0"/>
-              <a:t>DERK · ca. 2 min (IHK: Einsatzplanung, Teil von 20 Punkten).
+              <a:t>DERK · ca. 2 min (IHK: Einsatzplanung).
 Vier Phasen. In der Vorbereitung setzen wir um, was Valentin rechtlich gezeigt hat: Anmeldung, Auftragsverarbeitung, Einweisung.
 Sechs Wochen Parallelbetrieb: Die Rezeption prüft wie bisher, das System läuft mit. Erst bei mindestens 98 % Übereinstimmung und keinem übersehenen roten Fall geht es weiter.
 Die Phasen hängen direkt am Einsparziel aus dem Business Case: −50 % und −75 %.
@@ -3131,7 +3132,7 @@
           <a:p>
             <a:r>
               <a:rPr lang="en-US" dirty="0"/>
-              <a:t>THOMAS · ca. 1,5 min (IHK: Reflexion, roter Faden 15 Punkte).
+              <a:t>THOMAS · ca. 1,5 min (IHK: Reflexion, roter Faden).
 Vier Lernpunkte. Der zweite hat sich bis zuletzt bestätigt: Wo eine Regel feststeht, schlägt Code jedes noch so gute Prompting.
 Für künftige Projekte: erst die Praxis verstehen, dann bauen; früh messen; die rechtliche Einordnung hängt an der Zweckbestimmung; und die Tool-Auswahl ist nicht statisch.
 Auch die Teamarbeit erwähnen: Wechsel von vier auf drei Personen mit klarer Streichliste.</a:t>
@@ -3357,6 +3358,91 @@
 </p:notes>
 </file>
 
+<file path=ppt/notesSlides/notesSlide33.xml><?xml version="1.0" encoding="utf-8"?>
+<p:notes xmlns:a="http://schemas.openxmlformats.org/drawingml/2006/main" xmlns:p="http://schemas.openxmlformats.org/presentationml/2006/main" xmlns:r="http://schemas.openxmlformats.org/officeDocument/2006/relationships">
+  <p:cSld>
+    <p:spTree>
+      <p:nvGrpSpPr>
+        <p:cNvPr id="1" name=""/>
+        <p:cNvGrpSpPr/>
+        <p:nvPr/>
+      </p:nvGrpSpPr>
+      <p:grpSpPr>
+        <a:xfrm>
+          <a:off x="0" y="0"/>
+          <a:ext cx="0" cy="0"/>
+          <a:chOff x="0" y="0"/>
+          <a:chExt cx="0" cy="0"/>
+        </a:xfrm>
+      </p:grpSpPr>
+      <p:sp>
+        <p:nvSpPr>
+          <p:cNvPr id="2" name="Slide Image Placeholder 1"/>
+          <p:cNvSpPr>
+            <a:spLocks noGrp="1"/>
+          </p:cNvSpPr>
+          <p:nvPr>
+            <p:ph type="sldImg" idx="2"/>
+          </p:nvPr>
+        </p:nvSpPr>
+        <p:spPr/>
+      </p:sp>
+      <p:sp>
+        <p:nvSpPr>
+          <p:cNvPr id="3" name="Notes Placeholder 2"/>
+          <p:cNvSpPr>
+            <a:spLocks noGrp="1"/>
+          </p:cNvSpPr>
+          <p:nvPr>
+            <p:ph type="body" idx="3" sz="quarter"/>
+          </p:nvPr>
+        </p:nvSpPr>
+        <p:spPr/>
+        <p:txBody>
+          <a:bodyPr/>
+          <a:lstStyle/>
+          <a:p>
+            <a:r>
+              <a:t>DERK · ca. 1 min (IHK: Einsatzplanung, Prototyp als Anwendungsbeispiel).</a:t>
+            </a:r>
+          </a:p>
+          <a:p>
+            <a:r>
+              <a:t>Das ist der Workflow so, wie er in der n8n Cloud läuft. Von links: Eingang über Formular oder Chat, dann rechnet der Code die Fakten.</a:t>
+            </a:r>
+          </a:p>
+          <a:p>
+            <a:r>
+              <a:t>In der Mitte die vier Prüfer, rechts die Ampel, das Protokoll in Supabase und die Antwort an das Formular.</a:t>
+            </a:r>
+          </a:p>
+          <a:p>
+            <a:r>
+              <a:t>Merkpunkt: Was sich als Regel aufschreiben lässt, rechnet der Code. Das Sprachmodell formuliert und sucht im Regelwerk.</a:t>
+            </a:r>
+          </a:p>
+        </p:txBody>
+      </p:sp>
+      <p:sp>
+        <p:nvSpPr>
+          <p:cNvPr id="4" name="Slide Number Placeholder 3"/>
+          <p:cNvSpPr>
+            <a:spLocks noGrp="1"/>
+          </p:cNvSpPr>
+          <p:nvPr>
+            <p:ph type="sldNum" idx="5" sz="quarter"/>
+          </p:nvPr>
+        </p:nvSpPr>
+        <p:spPr/>
+      </p:sp>
+    </p:spTree>
+  </p:cSld>
+  <p:clrMapOvr>
+    <a:masterClrMapping/>
+  </p:clrMapOvr>
+</p:notes>
+</file>
+
 <file path=ppt/notesSlides/notesSlide4.xml><?xml version="1.0" encoding="utf-8"?>
 <p:notes xmlns:a="http://schemas.openxmlformats.org/drawingml/2006/main" xmlns:r="http://schemas.openxmlformats.org/officeDocument/2006/relationships" xmlns:p="http://schemas.openxmlformats.org/presentationml/2006/main">
   <p:cSld>
@@ -3494,7 +3580,7 @@
           <a:p>
             <a:r>
               <a:rPr lang="en-US" dirty="0"/>
-              <a:t>THOMAS · ca. 2 min (IHK: Ist/Soll, 10 Punkte).
+              <a:t>THOMAS · ca. 2 min (IHK: Ist/Soll).
 Ablauf heute: Die Rezeption prüft bei der Annahme (im Schnitt 6 min) und noch einmal vor der Abrechnung (ca. 2 min). Bei ca. 40 neuen Kassenverordnungen pro Woche sind das ca. 5,3 Stunden pro Woche.
 Kernaussage: 90 % der Fehler entstehen bei Doppel- und Folgeverordnungen. Die Praxissoftware zeigt nicht, wie viele Einheiten ein Patient beim selben Arzt schon hatte. Menschliche Doppelkontrollen sind höchstens ca. 85 % wirksam.
 Absetzungen: nur ca. 10 Fälle bzw. ca. 500 € pro Jahr. Der Hebel ist also die Prüfzeit, nicht die Absetzung.</a:t>
@@ -3585,7 +3671,7 @@
           <a:p>
             <a:r>
               <a:rPr lang="en-US" dirty="0"/>
-              <a:t>THOMAS · ca. 2,25 min (IHK: Einsatzfelder im Unternehmen, 10 Punkte).
+              <a:t>THOMAS · ca. 2,25 min (IHK: Einsatzfelder im Unternehmen).
 Bereiche Rezeption, Therapie und Verwaltung an beiden Standorten durchgegangen und jedes Einsatzfeld nach Nutzen und Machbarkeit eingeordnet.
 Terminvergabe hat hohen Nutzen, braucht aber eine Schnittstelle zur Praxissoftware. Abrechnung liegt beim Dienstleister. Therapieberichte enthalten Gesundheitsdaten im Freitext – höheres Risiko.
 Privatpraxis: Den Verordnungs-Check kann man dort nicht einfach übertragen. Für Privatpatienten gibt es kein Muster 13, keine Fristen und keine Höchstmengen. Das Risiko liegt woanders: Der Patient bleibt auf der Differenz zwischen Rechnung und Erstattung sitzen. Dafür passt ein Erstattungshinweis vor Behandlungsbeginn – ein Hinweis, keine Zusage.
@@ -21879,7 +21965,7 @@
                   <a:schemeClr val="tx2"/>
                 </a:solidFill>
               </a:rPr>
-              <a:t>IHK-Punkte: Ist/Soll 10 · Einsatzfelder 10 · Roter Faden 15</a:t>
+              <a:t>IHK-Kriterien: Ist/Soll · Einsatzfelder · Roter Faden</a:t>
             </a:r>
             <a:endParaRPr lang="en-US" sz="1200" dirty="0"/>
           </a:p>
@@ -22178,7 +22264,7 @@
                   <a:schemeClr val="accent1"/>
                 </a:solidFill>
               </a:rPr>
-              <a:t>IHK-Punkte: Tool-Vergleich 10 · Tool-Auswahl 10</a:t>
+              <a:t>IHK-Kriterien: Tool-Vergleich · Tool-Auswahl</a:t>
             </a:r>
             <a:endParaRPr lang="en-US" sz="1200" dirty="0"/>
           </a:p>
@@ -22495,7 +22581,7 @@
                   <a:schemeClr val="accent3"/>
                 </a:solidFill>
               </a:rPr>
-              <a:t>IHK-Punkte: Einsatzplanung 10 · Erfolgsmessung 10</a:t>
+              <a:t>IHK-Kriterien: Einsatzplanung · Erfolgsmessung</a:t>
             </a:r>
             <a:endParaRPr lang="en-US" sz="1200" dirty="0"/>
           </a:p>
@@ -22531,7 +22617,7 @@
                   <a:schemeClr val="tx2"/>
                 </a:solidFill>
               </a:rPr>
-              <a:t>Gesamt ca. 45 min · Orthografie und Schreibstil (25 Punkte) verantworten wir gemeinsam im Vier-Augen-Prinzip</a:t>
+              <a:t>Gesamt ca. 45 min · Orthografie und Schreibstil verantworten wir gemeinsam im Vier-Augen-Prinzip</a:t>
             </a:r>
             <a:endParaRPr lang="en-US" sz="1300" dirty="0"/>
           </a:p>
@@ -42840,6 +42926,523 @@
           </a:p>
         </p:txBody>
       </p:sp>
+    </p:spTree>
+  </p:cSld>
+  <p:clrMapOvr>
+    <a:masterClrMapping/>
+  </p:clrMapOvr>
+</p:sld>
+</file>
+
+<file path=ppt/slides/slide33.xml><?xml version="1.0" encoding="utf-8"?>
+<p:sld xmlns:a="http://schemas.openxmlformats.org/drawingml/2006/main" xmlns:p="http://schemas.openxmlformats.org/presentationml/2006/main" xmlns:r="http://schemas.openxmlformats.org/officeDocument/2006/relationships">
+  <p:cSld>
+    <p:spTree>
+      <p:nvGrpSpPr>
+        <p:cNvPr id="2" name=""/>
+        <p:cNvGrpSpPr/>
+        <p:nvPr/>
+      </p:nvGrpSpPr>
+      <p:grpSpPr/>
+      <p:sp>
+        <p:nvSpPr>
+          <p:cNvPr id="3" name="Text 0"/>
+          <p:cNvSpPr/>
+          <p:nvPr>
+            <p:ph idx="100" type="title" hasCustomPrompt="1"/>
+          </p:nvPr>
+        </p:nvSpPr>
+        <p:spPr>
+          <a:xfrm>
+            <a:off x="548640" y="347472"/>
+            <a:ext cx="9326880" cy="685800"/>
+          </a:xfrm>
+          <a:prstGeom prst="rect">
+            <a:avLst/>
+          </a:prstGeom>
+          <a:noFill/>
+          <a:ln/>
+        </p:spPr>
+        <p:txBody>
+          <a:bodyPr wrap="square" lIns="0" tIns="0" rIns="0" bIns="0" rtlCol="0" anchor="ctr"/>
+          <a:lstStyle/>
+          <a:p>
+            <a:pPr algn="l" indent="0" marL="0">
+              <a:buNone/>
+            </a:pPr>
+            <a:r>
+              <a:rPr lang="en-US" sz="2800" b="1" dirty="0">
+                <a:solidFill>
+                  <a:schemeClr val="tx2"/>
+                </a:solidFill>
+                <a:latin typeface="Cambria" pitchFamily="34" charset="0"/>
+                <a:ea typeface="Cambria" pitchFamily="34" charset="-122"/>
+                <a:cs typeface="Cambria" pitchFamily="34" charset="-120"/>
+              </a:rPr>
+              <a:t>Der Workflow in n8n: vom Formular zur Ampel</a:t>
+            </a:r>
+            <a:endParaRPr lang="en-US" sz="2800" dirty="0"/>
+          </a:p>
+        </p:txBody>
+      </p:sp>
+      <p:sp>
+        <p:nvSpPr>
+          <p:cNvPr id="4" name="Rolleninhaber"/>
+          <p:cNvSpPr/>
+          <p:nvPr/>
+        </p:nvSpPr>
+        <p:spPr>
+          <a:xfrm>
+            <a:off x="10195560" y="457200"/>
+            <a:ext cx="1463040" cy="438912"/>
+          </a:xfrm>
+          <a:prstGeom prst="roundRect">
+            <a:avLst>
+              <a:gd name="adj" fmla="val 50000"/>
+            </a:avLst>
+          </a:prstGeom>
+          <a:solidFill>
+            <a:schemeClr val="accent3"/>
+          </a:solidFill>
+          <a:ln/>
+        </p:spPr>
+        <p:txBody>
+          <a:bodyPr/>
+          <a:p/>
+        </p:txBody>
+      </p:sp>
+      <p:pic>
+        <p:nvPicPr>
+          <p:cNvPr id="5" name="Personen-Symbol" descr="preencoded.png">    </p:cNvPr>
+          <p:cNvPicPr>
+            <a:picLocks noChangeAspect="1"/>
+          </p:cNvPicPr>
+          <p:nvPr/>
+        </p:nvPicPr>
+        <p:blipFill>
+          <a:blip r:embed="rId2"/>
+          <a:stretch>
+            <a:fillRect/>
+          </a:stretch>
+        </p:blipFill>
+        <p:spPr>
+          <a:xfrm>
+            <a:off x="10332720" y="548640"/>
+            <a:ext cx="256032" cy="256032"/>
+          </a:xfrm>
+          <a:prstGeom prst="rect">
+            <a:avLst/>
+          </a:prstGeom>
+        </p:spPr>
+      </p:pic>
+      <p:sp>
+        <p:nvSpPr>
+          <p:cNvPr id="6" name="Name Rolleninhaber"/>
+          <p:cNvSpPr txBox="1"/>
+          <p:nvPr/>
+        </p:nvSpPr>
+        <p:spPr>
+          <a:xfrm>
+            <a:off x="10625328" y="457200"/>
+            <a:ext cx="960120" cy="438912"/>
+          </a:xfrm>
+          <a:prstGeom prst="rect">
+            <a:avLst/>
+          </a:prstGeom>
+          <a:noFill/>
+          <a:ln/>
+        </p:spPr>
+        <p:txBody>
+          <a:bodyPr wrap="square" lIns="0" tIns="0" rIns="0" bIns="0" rtlCol="0" anchor="ctr"/>
+          <a:lstStyle/>
+          <a:p>
+            <a:pPr indent="0" marL="0">
+              <a:buNone/>
+            </a:pPr>
+            <a:r>
+              <a:rPr lang="en-US" sz="1500" b="1" dirty="0">
+                <a:solidFill>
+                  <a:schemeClr val="bg1"/>
+                </a:solidFill>
+              </a:rPr>
+              <a:t>Derk</a:t>
+            </a:r>
+            <a:endParaRPr lang="en-US" sz="1500" dirty="0"/>
+          </a:p>
+        </p:txBody>
+      </p:sp>
+      <p:sp>
+        <p:nvSpPr>
+          <p:cNvPr id="7" name="Slide Number Placeholder 0"/>
+          <p:cNvSpPr>
+            <a:spLocks noGrp="1"/>
+          </p:cNvSpPr>
+          <p:nvPr>
+            <p:ph type="sldNum" sz="quarter" idx="4294967295"/>
+          </p:nvPr>
+        </p:nvSpPr>
+        <p:spPr>
+          <a:xfrm>
+            <a:off x="11201400" y="6419088"/>
+            <a:ext cx="457200" cy="274320"/>
+          </a:xfrm>
+          <a:prstGeom prst="rect">
+            <a:avLst/>
+          </a:prstGeom>
+          <a:extLst>
+            <a:ext uri="{C572A759-6A51-4108-AA02-DFA0A04FC94B}">
+              <ma14:wrappingTextBoxFlag xmlns:ma14="http://schemas.microsoft.com/office/mac/drawingml/2011/main" val="0"/>
+            </a:ext>
+          </a:extLst>
+        </p:spPr>
+        <p:txBody>
+          <a:bodyPr/>
+          <a:lstStyle>
+            <a:lvl1pPr>
+              <a:defRPr sz="1000">
+                <a:solidFill>
+                  <a:schemeClr val="accent5"/>
+                </a:solidFill>
+                <a:latin typeface="Calibri"/>
+                <a:ea typeface="Calibri"/>
+                <a:cs typeface="Calibri"/>
+              </a:defRPr>
+            </a:lvl1pPr>
+          </a:lstStyle>
+          <a:p>
+            <a:pPr algn="r"/>
+            <a:fld id="{F7021451-1387-4CA6-816F-3879F97B5CBC}" type="slidenum">
+              <a:rPr b="0" lang="en-US"/>
+              <a:t>22</a:t>
+            </a:fld>
+            <a:endParaRPr lang="en-US"/>
+          </a:p>
+        </p:txBody>
+      </p:sp>
+      <p:sp>
+        <p:nvSpPr>
+          <p:cNvPr id="8" name="Einordnung"/>
+          <p:cNvSpPr/>
+          <p:nvPr/>
+        </p:nvSpPr>
+        <p:spPr>
+          <a:xfrm>
+            <a:off x="8625840" y="1325880"/>
+            <a:ext cx="3014472" cy="4526280"/>
+          </a:xfrm>
+          <a:prstGeom prst="roundRect">
+            <a:avLst>
+              <a:gd name="adj" fmla="val 2010"/>
+            </a:avLst>
+          </a:prstGeom>
+          <a:solidFill>
+            <a:schemeClr val="tx2"/>
+          </a:solidFill>
+          <a:ln/>
+        </p:spPr>
+        <p:txBody>
+          <a:bodyPr/>
+          <a:p/>
+        </p:txBody>
+      </p:sp>
+      <p:sp>
+        <p:nvSpPr>
+          <p:cNvPr id="9" name="Text 4"/>
+          <p:cNvSpPr txBox="1"/>
+          <p:nvPr/>
+        </p:nvSpPr>
+        <p:spPr>
+          <a:xfrm>
+            <a:off x="8854440" y="1463040"/>
+            <a:ext cx="2557272" cy="384048"/>
+          </a:xfrm>
+          <a:prstGeom prst="rect">
+            <a:avLst/>
+          </a:prstGeom>
+          <a:noFill/>
+          <a:ln/>
+        </p:spPr>
+        <p:txBody>
+          <a:bodyPr wrap="square" lIns="0" tIns="0" rIns="0" bIns="0" rtlCol="0" anchor="t"/>
+          <a:lstStyle/>
+          <a:p>
+            <a:pPr indent="0" marL="0">
+              <a:buNone/>
+            </a:pPr>
+            <a:r>
+              <a:rPr lang="en-US" sz="1800" b="1" dirty="0">
+                <a:solidFill>
+                  <a:schemeClr val="bg1"/>
+                </a:solidFill>
+                <a:latin typeface="Cambria" pitchFamily="34" charset="0"/>
+                <a:ea typeface="Cambria" pitchFamily="34" charset="-122"/>
+                <a:cs typeface="Cambria" pitchFamily="34" charset="-120"/>
+              </a:rPr>
+              <a:t>Was man sieht</a:t>
+            </a:r>
+            <a:endParaRPr lang="en-US" sz="1800" dirty="0"/>
+          </a:p>
+        </p:txBody>
+      </p:sp>
+      <p:sp>
+        <p:nvSpPr>
+          <p:cNvPr id="10" name="Text 5"/>
+          <p:cNvSpPr txBox="1"/>
+          <p:nvPr/>
+        </p:nvSpPr>
+        <p:spPr>
+          <a:xfrm>
+            <a:off x="8854440" y="1965960"/>
+            <a:ext cx="2557272" cy="3749040"/>
+          </a:xfrm>
+          <a:prstGeom prst="rect">
+            <a:avLst/>
+          </a:prstGeom>
+          <a:noFill/>
+          <a:ln/>
+        </p:spPr>
+        <p:txBody>
+          <a:bodyPr wrap="square" lIns="0" tIns="0" rIns="0" bIns="0" rtlCol="0" anchor="t"/>
+          <a:lstStyle/>
+          <a:p>
+            <a:pPr marL="177800" indent="-177800">
+              <a:spcAft>
+                <a:spcPts val="500"/>
+              </a:spcAft>
+              <a:buSzPct val="100000"/>
+              <a:buChar char="•"/>
+            </a:pPr>
+            <a:r>
+              <a:rPr lang="en-US" sz="1300" dirty="0">
+                <a:solidFill>
+                  <a:schemeClr val="bg1"/>
+                </a:solidFill>
+              </a:rPr>
+              <a:t>35 Knoten, ein Workflow für Formular und Chat</a:t>
+            </a:r>
+            <a:endParaRPr lang="en-US" sz="1400" dirty="0"/>
+          </a:p>
+          <a:p>
+            <a:pPr marL="177800" indent="-177800">
+              <a:spcAft>
+                <a:spcPts val="500"/>
+              </a:spcAft>
+              <a:buSzPct val="100000"/>
+              <a:buChar char="•"/>
+            </a:pPr>
+            <a:r>
+              <a:rPr lang="en-US" sz="1300" dirty="0">
+                <a:solidFill>
+                  <a:schemeClr val="bg1"/>
+                </a:solidFill>
+              </a:rPr>
+              <a:t>Code-Knoten rechnen Fristen, Höchstmenge, Leitsymptomatik und Frequenz</a:t>
+            </a:r>
+            <a:endParaRPr lang="en-US" sz="1400" dirty="0"/>
+          </a:p>
+          <a:p>
+            <a:pPr marL="177800" indent="-177800">
+              <a:spcAft>
+                <a:spcPts val="500"/>
+              </a:spcAft>
+              <a:buSzPct val="100000"/>
+              <a:buChar char="•"/>
+            </a:pPr>
+            <a:r>
+              <a:rPr lang="en-US" sz="1300" dirty="0">
+                <a:solidFill>
+                  <a:schemeClr val="bg1"/>
+                </a:solidFill>
+              </a:rPr>
+              <a:t>Vier Prüf-Agenten: Formal, Diagnose, Mengen, Fristen</a:t>
+            </a:r>
+            <a:endParaRPr lang="en-US" sz="1400" dirty="0"/>
+          </a:p>
+          <a:p>
+            <a:pPr marL="177800" indent="-177800">
+              <a:spcAft>
+                <a:spcPts val="500"/>
+              </a:spcAft>
+              <a:buSzPct val="100000"/>
+              <a:buChar char="•"/>
+            </a:pPr>
+            <a:r>
+              <a:rPr lang="en-US" sz="1300" dirty="0">
+                <a:solidFill>
+                  <a:schemeClr val="bg1"/>
+                </a:solidFill>
+              </a:rPr>
+              <a:t>Die Ampel bildet der Code aus den Befunden</a:t>
+            </a:r>
+            <a:endParaRPr lang="en-US" sz="1400" dirty="0"/>
+          </a:p>
+          <a:p>
+            <a:pPr marL="177800" indent="-177800">
+              <a:spcAft>
+                <a:spcPts val="500"/>
+              </a:spcAft>
+              <a:buSzPct val="100000"/>
+              <a:buChar char="•"/>
+            </a:pPr>
+            <a:r>
+              <a:rPr lang="en-US" sz="1300" dirty="0">
+                <a:solidFill>
+                  <a:schemeClr val="bg1"/>
+                </a:solidFill>
+              </a:rPr>
+              <a:t>Test-Läufe: Median 34 s je Prüfung</a:t>
+            </a:r>
+            <a:endParaRPr lang="en-US" sz="1400" dirty="0"/>
+          </a:p>
+          <a:p>
+            <a:pPr marL="0" indent="0">
+              <a:spcBef>
+                <a:spcPts val="1800"/>
+              </a:spcBef>
+              <a:spcAft>
+                <a:spcPts val="500"/>
+              </a:spcAft>
+              <a:buNone/>
+            </a:pPr>
+            <a:r>
+              <a:rPr lang="en-US" sz="1300" dirty="0" b="1">
+                <a:solidFill>
+                  <a:schemeClr val="bg1"/>
+                </a:solidFill>
+              </a:rPr>
+              <a:t>Merkpunkt: Was sich als Regel aufschreiben lässt, rechnet der Code.</a:t>
+            </a:r>
+            <a:endParaRPr lang="en-US" sz="1400" dirty="0"/>
+          </a:p>
+        </p:txBody>
+      </p:sp>
+      <p:sp>
+        <p:nvSpPr>
+          <p:cNvPr id="11" name="Text 6"/>
+          <p:cNvSpPr txBox="1"/>
+          <p:nvPr/>
+        </p:nvSpPr>
+        <p:spPr>
+          <a:xfrm>
+            <a:off x="548640" y="6035040"/>
+            <a:ext cx="11064240" cy="329184"/>
+          </a:xfrm>
+          <a:prstGeom prst="rect">
+            <a:avLst/>
+          </a:prstGeom>
+          <a:noFill/>
+          <a:ln/>
+        </p:spPr>
+        <p:txBody>
+          <a:bodyPr wrap="square" lIns="0" tIns="0" rIns="0" bIns="0" rtlCol="0" anchor="t"/>
+          <a:lstStyle/>
+          <a:p>
+            <a:pPr indent="0" marL="0">
+              <a:buNone/>
+            </a:pPr>
+            <a:r>
+              <a:rPr lang="en-US" sz="1000" i="1" dirty="0">
+                <a:solidFill>
+                  <a:schemeClr val="accent5"/>
+                </a:solidFill>
+              </a:rPr>
+              <a:t>Screenshot aus der n8n Cloud, Workflow „Verordnungcheck_gemerged“ · Stand 28.10.2026</a:t>
+            </a:r>
+            <a:endParaRPr lang="en-US" sz="1000" dirty="0"/>
+          </a:p>
+        </p:txBody>
+      </p:sp>
+      <p:sp>
+        <p:nvSpPr>
+          <p:cNvPr id="12" name="Werkzeug"/>
+          <p:cNvSpPr/>
+          <p:nvPr/>
+        </p:nvSpPr>
+        <p:spPr>
+          <a:xfrm>
+            <a:off x="548640" y="5336505"/>
+            <a:ext cx="7905750" cy="515655"/>
+          </a:xfrm>
+          <a:prstGeom prst="roundRect">
+            <a:avLst>
+              <a:gd name="adj" fmla="val 3200"/>
+            </a:avLst>
+          </a:prstGeom>
+          <a:solidFill>
+            <a:schemeClr val="bg2"/>
+          </a:solidFill>
+          <a:ln/>
+        </p:spPr>
+        <p:txBody>
+          <a:bodyPr/>
+          <a:p/>
+        </p:txBody>
+      </p:sp>
+      <p:sp>
+        <p:nvSpPr>
+          <p:cNvPr id="13" name="Text 20"/>
+          <p:cNvSpPr txBox="1"/>
+          <p:nvPr/>
+        </p:nvSpPr>
+        <p:spPr>
+          <a:xfrm>
+            <a:off x="731520" y="5409657"/>
+            <a:ext cx="7539990" cy="369351"/>
+          </a:xfrm>
+          <a:prstGeom prst="rect">
+            <a:avLst/>
+          </a:prstGeom>
+          <a:noFill/>
+          <a:ln/>
+        </p:spPr>
+        <p:txBody>
+          <a:bodyPr wrap="square" lIns="0" tIns="0" rIns="0" bIns="0" rtlCol="0" anchor="t"/>
+          <a:lstStyle/>
+          <a:p>
+            <a:pPr indent="0" marL="0">
+              <a:buNone/>
+            </a:pPr>
+            <a:r>
+              <a:rPr lang="en-US" sz="1300" dirty="0">
+                <a:solidFill>
+                  <a:schemeClr val="tx1"/>
+                </a:solidFill>
+              </a:rPr>
+              <a:t>Lesen von links nach rechts: Eingang (Formular oder Chat) → Fakten im Code → vier Prüfer → Ampel → Protokoll in Supabase → Antwort an das Formular.</a:t>
+            </a:r>
+            <a:endParaRPr lang="en-US" sz="1400" dirty="0"/>
+          </a:p>
+        </p:txBody>
+      </p:sp>
+      <p:pic>
+        <p:nvPicPr>
+          <p:cNvPr id="14" name="Screenshot n8n Workflow" descr="n8n-workflow.png"/>
+          <p:cNvPicPr>
+            <a:picLocks noChangeAspect="1"/>
+          </p:cNvPicPr>
+          <p:nvPr/>
+        </p:nvPicPr>
+        <p:blipFill>
+          <a:blip r:embed="rId3"/>
+          <a:stretch>
+            <a:fillRect/>
+          </a:stretch>
+        </p:blipFill>
+        <p:spPr>
+          <a:xfrm>
+            <a:off x="548640" y="1325880"/>
+            <a:ext cx="7905750" cy="3919185"/>
+          </a:xfrm>
+          <a:prstGeom prst="rect">
+            <a:avLst/>
+          </a:prstGeom>
+          <a:ln w="9525">
+            <a:solidFill>
+              <a:srgbClr val="C9D3D0"/>
+            </a:solidFill>
+          </a:ln>
+        </p:spPr>
+      </p:pic>
     </p:spTree>
   </p:cSld>
   <p:clrMapOvr>

</xml_diff>

<commit_message>
Präsentation Folie 3 und 5: Abrechnungsdienstleister 1,9 % statt 3–6 %
Co-Authored-By: Claude Sonnet 5.5 <noreply@anthropic.com>
Claude-Session: https://claude.ai/code/session_01Fiy9oFcgEmSsPPtPA47rVp
</commit_message>
<xml_diff>
--- a/docs/praesentation/Verordnungs-Check_IHK_3x15min_2026-10-27.pptx
+++ b/docs/praesentation/Verordnungs-Check_IHK_3x15min_2026-10-27.pptx
@@ -26171,6 +26171,523 @@
 </file>
 
 <file path=ppt/slides/slide22.xml><?xml version="1.0" encoding="utf-8"?>
+<p:sld xmlns:a="http://schemas.openxmlformats.org/drawingml/2006/main" xmlns:p="http://schemas.openxmlformats.org/presentationml/2006/main" xmlns:r="http://schemas.openxmlformats.org/officeDocument/2006/relationships">
+  <p:cSld>
+    <p:spTree>
+      <p:nvGrpSpPr>
+        <p:cNvPr id="2" name=""/>
+        <p:cNvGrpSpPr/>
+        <p:nvPr/>
+      </p:nvGrpSpPr>
+      <p:grpSpPr/>
+      <p:sp>
+        <p:nvSpPr>
+          <p:cNvPr id="3" name="Text 0"/>
+          <p:cNvSpPr/>
+          <p:nvPr>
+            <p:ph idx="100" type="title" hasCustomPrompt="1"/>
+          </p:nvPr>
+        </p:nvSpPr>
+        <p:spPr>
+          <a:xfrm>
+            <a:off x="548640" y="347472"/>
+            <a:ext cx="9326880" cy="685800"/>
+          </a:xfrm>
+          <a:prstGeom prst="rect">
+            <a:avLst/>
+          </a:prstGeom>
+          <a:noFill/>
+          <a:ln/>
+        </p:spPr>
+        <p:txBody>
+          <a:bodyPr wrap="square" lIns="0" tIns="0" rIns="0" bIns="0" rtlCol="0" anchor="ctr"/>
+          <a:lstStyle/>
+          <a:p>
+            <a:pPr algn="l" indent="0" marL="0">
+              <a:buNone/>
+            </a:pPr>
+            <a:r>
+              <a:rPr lang="en-US" sz="2800" b="1" dirty="0">
+                <a:solidFill>
+                  <a:schemeClr val="tx2"/>
+                </a:solidFill>
+                <a:latin typeface="Cambria" pitchFamily="34" charset="0"/>
+                <a:ea typeface="Cambria" pitchFamily="34" charset="-122"/>
+                <a:cs typeface="Cambria" pitchFamily="34" charset="-120"/>
+              </a:rPr>
+              <a:t>Der Workflow in n8n: vom Formular zur Ampel</a:t>
+            </a:r>
+            <a:endParaRPr lang="en-US" sz="2800" dirty="0"/>
+          </a:p>
+        </p:txBody>
+      </p:sp>
+      <p:sp>
+        <p:nvSpPr>
+          <p:cNvPr id="4" name="Rolleninhaber"/>
+          <p:cNvSpPr/>
+          <p:nvPr/>
+        </p:nvSpPr>
+        <p:spPr>
+          <a:xfrm>
+            <a:off x="10195560" y="457200"/>
+            <a:ext cx="1463040" cy="438912"/>
+          </a:xfrm>
+          <a:prstGeom prst="roundRect">
+            <a:avLst>
+              <a:gd name="adj" fmla="val 50000"/>
+            </a:avLst>
+          </a:prstGeom>
+          <a:solidFill>
+            <a:schemeClr val="accent3"/>
+          </a:solidFill>
+          <a:ln/>
+        </p:spPr>
+        <p:txBody>
+          <a:bodyPr/>
+          <a:p/>
+        </p:txBody>
+      </p:sp>
+      <p:pic>
+        <p:nvPicPr>
+          <p:cNvPr id="5" name="Personen-Symbol" descr="preencoded.png">    </p:cNvPr>
+          <p:cNvPicPr>
+            <a:picLocks noChangeAspect="1"/>
+          </p:cNvPicPr>
+          <p:nvPr/>
+        </p:nvPicPr>
+        <p:blipFill>
+          <a:blip r:embed="rId2"/>
+          <a:stretch>
+            <a:fillRect/>
+          </a:stretch>
+        </p:blipFill>
+        <p:spPr>
+          <a:xfrm>
+            <a:off x="10332720" y="548640"/>
+            <a:ext cx="256032" cy="256032"/>
+          </a:xfrm>
+          <a:prstGeom prst="rect">
+            <a:avLst/>
+          </a:prstGeom>
+        </p:spPr>
+      </p:pic>
+      <p:sp>
+        <p:nvSpPr>
+          <p:cNvPr id="6" name="Name Rolleninhaber"/>
+          <p:cNvSpPr txBox="1"/>
+          <p:nvPr/>
+        </p:nvSpPr>
+        <p:spPr>
+          <a:xfrm>
+            <a:off x="10625328" y="457200"/>
+            <a:ext cx="960120" cy="438912"/>
+          </a:xfrm>
+          <a:prstGeom prst="rect">
+            <a:avLst/>
+          </a:prstGeom>
+          <a:noFill/>
+          <a:ln/>
+        </p:spPr>
+        <p:txBody>
+          <a:bodyPr wrap="square" lIns="0" tIns="0" rIns="0" bIns="0" rtlCol="0" anchor="ctr"/>
+          <a:lstStyle/>
+          <a:p>
+            <a:pPr indent="0" marL="0">
+              <a:buNone/>
+            </a:pPr>
+            <a:r>
+              <a:rPr lang="en-US" sz="1500" b="1" dirty="0">
+                <a:solidFill>
+                  <a:schemeClr val="bg1"/>
+                </a:solidFill>
+              </a:rPr>
+              <a:t>Derk</a:t>
+            </a:r>
+            <a:endParaRPr lang="en-US" sz="1500" dirty="0"/>
+          </a:p>
+        </p:txBody>
+      </p:sp>
+      <p:sp>
+        <p:nvSpPr>
+          <p:cNvPr id="7" name="Slide Number Placeholder 0"/>
+          <p:cNvSpPr>
+            <a:spLocks noGrp="1"/>
+          </p:cNvSpPr>
+          <p:nvPr>
+            <p:ph type="sldNum" sz="quarter" idx="4294967295"/>
+          </p:nvPr>
+        </p:nvSpPr>
+        <p:spPr>
+          <a:xfrm>
+            <a:off x="11201400" y="6419088"/>
+            <a:ext cx="457200" cy="274320"/>
+          </a:xfrm>
+          <a:prstGeom prst="rect">
+            <a:avLst/>
+          </a:prstGeom>
+          <a:extLst>
+            <a:ext uri="{C572A759-6A51-4108-AA02-DFA0A04FC94B}">
+              <ma14:wrappingTextBoxFlag xmlns:ma14="http://schemas.microsoft.com/office/mac/drawingml/2011/main" val="0"/>
+            </a:ext>
+          </a:extLst>
+        </p:spPr>
+        <p:txBody>
+          <a:bodyPr/>
+          <a:lstStyle>
+            <a:lvl1pPr>
+              <a:defRPr sz="1000">
+                <a:solidFill>
+                  <a:schemeClr val="accent5"/>
+                </a:solidFill>
+                <a:latin typeface="Calibri"/>
+                <a:ea typeface="Calibri"/>
+                <a:cs typeface="Calibri"/>
+              </a:defRPr>
+            </a:lvl1pPr>
+          </a:lstStyle>
+          <a:p>
+            <a:pPr algn="r"/>
+            <a:fld id="{F7021451-1387-4CA6-816F-3879F97B5CBC}" type="slidenum">
+              <a:rPr b="0" lang="en-US"/>
+              <a:t>22</a:t>
+            </a:fld>
+            <a:endParaRPr lang="en-US"/>
+          </a:p>
+        </p:txBody>
+      </p:sp>
+      <p:sp>
+        <p:nvSpPr>
+          <p:cNvPr id="8" name="Einordnung"/>
+          <p:cNvSpPr/>
+          <p:nvPr/>
+        </p:nvSpPr>
+        <p:spPr>
+          <a:xfrm>
+            <a:off x="8625840" y="1325880"/>
+            <a:ext cx="3014472" cy="4526280"/>
+          </a:xfrm>
+          <a:prstGeom prst="roundRect">
+            <a:avLst>
+              <a:gd name="adj" fmla="val 2010"/>
+            </a:avLst>
+          </a:prstGeom>
+          <a:solidFill>
+            <a:schemeClr val="tx2"/>
+          </a:solidFill>
+          <a:ln/>
+        </p:spPr>
+        <p:txBody>
+          <a:bodyPr/>
+          <a:p/>
+        </p:txBody>
+      </p:sp>
+      <p:sp>
+        <p:nvSpPr>
+          <p:cNvPr id="9" name="Text 4"/>
+          <p:cNvSpPr txBox="1"/>
+          <p:nvPr/>
+        </p:nvSpPr>
+        <p:spPr>
+          <a:xfrm>
+            <a:off x="8854440" y="1463040"/>
+            <a:ext cx="2557272" cy="384048"/>
+          </a:xfrm>
+          <a:prstGeom prst="rect">
+            <a:avLst/>
+          </a:prstGeom>
+          <a:noFill/>
+          <a:ln/>
+        </p:spPr>
+        <p:txBody>
+          <a:bodyPr wrap="square" lIns="0" tIns="0" rIns="0" bIns="0" rtlCol="0" anchor="t"/>
+          <a:lstStyle/>
+          <a:p>
+            <a:pPr indent="0" marL="0">
+              <a:buNone/>
+            </a:pPr>
+            <a:r>
+              <a:rPr lang="en-US" sz="1800" b="1" dirty="0">
+                <a:solidFill>
+                  <a:schemeClr val="bg1"/>
+                </a:solidFill>
+                <a:latin typeface="Cambria" pitchFamily="34" charset="0"/>
+                <a:ea typeface="Cambria" pitchFamily="34" charset="-122"/>
+                <a:cs typeface="Cambria" pitchFamily="34" charset="-120"/>
+              </a:rPr>
+              <a:t>Was man sieht</a:t>
+            </a:r>
+            <a:endParaRPr lang="en-US" sz="1800" dirty="0"/>
+          </a:p>
+        </p:txBody>
+      </p:sp>
+      <p:sp>
+        <p:nvSpPr>
+          <p:cNvPr id="10" name="Text 5"/>
+          <p:cNvSpPr txBox="1"/>
+          <p:nvPr/>
+        </p:nvSpPr>
+        <p:spPr>
+          <a:xfrm>
+            <a:off x="8854440" y="1965960"/>
+            <a:ext cx="2557272" cy="3749040"/>
+          </a:xfrm>
+          <a:prstGeom prst="rect">
+            <a:avLst/>
+          </a:prstGeom>
+          <a:noFill/>
+          <a:ln/>
+        </p:spPr>
+        <p:txBody>
+          <a:bodyPr wrap="square" lIns="0" tIns="0" rIns="0" bIns="0" rtlCol="0" anchor="t"/>
+          <a:lstStyle/>
+          <a:p>
+            <a:pPr marL="177800" indent="-177800">
+              <a:spcAft>
+                <a:spcPts val="500"/>
+              </a:spcAft>
+              <a:buSzPct val="100000"/>
+              <a:buChar char="•"/>
+            </a:pPr>
+            <a:r>
+              <a:rPr lang="en-US" sz="1300" dirty="0">
+                <a:solidFill>
+                  <a:schemeClr val="bg1"/>
+                </a:solidFill>
+              </a:rPr>
+              <a:t>35 Knoten, ein Workflow für Formular und Chat</a:t>
+            </a:r>
+            <a:endParaRPr lang="en-US" sz="1400" dirty="0"/>
+          </a:p>
+          <a:p>
+            <a:pPr marL="177800" indent="-177800">
+              <a:spcAft>
+                <a:spcPts val="500"/>
+              </a:spcAft>
+              <a:buSzPct val="100000"/>
+              <a:buChar char="•"/>
+            </a:pPr>
+            <a:r>
+              <a:rPr lang="en-US" sz="1300" dirty="0">
+                <a:solidFill>
+                  <a:schemeClr val="bg1"/>
+                </a:solidFill>
+              </a:rPr>
+              <a:t>Code-Knoten rechnen Fristen, Höchstmenge, Leitsymptomatik und Frequenz</a:t>
+            </a:r>
+            <a:endParaRPr lang="en-US" sz="1400" dirty="0"/>
+          </a:p>
+          <a:p>
+            <a:pPr marL="177800" indent="-177800">
+              <a:spcAft>
+                <a:spcPts val="500"/>
+              </a:spcAft>
+              <a:buSzPct val="100000"/>
+              <a:buChar char="•"/>
+            </a:pPr>
+            <a:r>
+              <a:rPr lang="en-US" sz="1300" dirty="0">
+                <a:solidFill>
+                  <a:schemeClr val="bg1"/>
+                </a:solidFill>
+              </a:rPr>
+              <a:t>Vier Prüf-Agenten: Formal, Diagnose, Mengen, Fristen</a:t>
+            </a:r>
+            <a:endParaRPr lang="en-US" sz="1400" dirty="0"/>
+          </a:p>
+          <a:p>
+            <a:pPr marL="177800" indent="-177800">
+              <a:spcAft>
+                <a:spcPts val="500"/>
+              </a:spcAft>
+              <a:buSzPct val="100000"/>
+              <a:buChar char="•"/>
+            </a:pPr>
+            <a:r>
+              <a:rPr lang="en-US" sz="1300" dirty="0">
+                <a:solidFill>
+                  <a:schemeClr val="bg1"/>
+                </a:solidFill>
+              </a:rPr>
+              <a:t>Die Ampel bildet der Code aus den Befunden</a:t>
+            </a:r>
+            <a:endParaRPr lang="en-US" sz="1400" dirty="0"/>
+          </a:p>
+          <a:p>
+            <a:pPr marL="177800" indent="-177800">
+              <a:spcAft>
+                <a:spcPts val="500"/>
+              </a:spcAft>
+              <a:buSzPct val="100000"/>
+              <a:buChar char="•"/>
+            </a:pPr>
+            <a:r>
+              <a:rPr lang="en-US" sz="1300" dirty="0">
+                <a:solidFill>
+                  <a:schemeClr val="bg1"/>
+                </a:solidFill>
+              </a:rPr>
+              <a:t>Test-Läufe: Median 34 s je Prüfung</a:t>
+            </a:r>
+            <a:endParaRPr lang="en-US" sz="1400" dirty="0"/>
+          </a:p>
+          <a:p>
+            <a:pPr marL="0" indent="0">
+              <a:spcBef>
+                <a:spcPts val="1800"/>
+              </a:spcBef>
+              <a:spcAft>
+                <a:spcPts val="500"/>
+              </a:spcAft>
+              <a:buNone/>
+            </a:pPr>
+            <a:r>
+              <a:rPr lang="en-US" sz="1300" dirty="0" b="1">
+                <a:solidFill>
+                  <a:schemeClr val="bg1"/>
+                </a:solidFill>
+              </a:rPr>
+              <a:t>Merkpunkt: Was sich als Regel aufschreiben lässt, rechnet der Code.</a:t>
+            </a:r>
+            <a:endParaRPr lang="en-US" sz="1400" dirty="0"/>
+          </a:p>
+        </p:txBody>
+      </p:sp>
+      <p:sp>
+        <p:nvSpPr>
+          <p:cNvPr id="11" name="Text 6"/>
+          <p:cNvSpPr txBox="1"/>
+          <p:nvPr/>
+        </p:nvSpPr>
+        <p:spPr>
+          <a:xfrm>
+            <a:off x="548640" y="6035040"/>
+            <a:ext cx="11064240" cy="329184"/>
+          </a:xfrm>
+          <a:prstGeom prst="rect">
+            <a:avLst/>
+          </a:prstGeom>
+          <a:noFill/>
+          <a:ln/>
+        </p:spPr>
+        <p:txBody>
+          <a:bodyPr wrap="square" lIns="0" tIns="0" rIns="0" bIns="0" rtlCol="0" anchor="t"/>
+          <a:lstStyle/>
+          <a:p>
+            <a:pPr indent="0" marL="0">
+              <a:buNone/>
+            </a:pPr>
+            <a:r>
+              <a:rPr lang="en-US" sz="1000" i="1" dirty="0">
+                <a:solidFill>
+                  <a:schemeClr val="accent5"/>
+                </a:solidFill>
+              </a:rPr>
+              <a:t>Screenshot aus der n8n Cloud, Workflow „Verordnungcheck_gemerged“ · Stand 28.10.2026</a:t>
+            </a:r>
+            <a:endParaRPr lang="en-US" sz="1000" dirty="0"/>
+          </a:p>
+        </p:txBody>
+      </p:sp>
+      <p:sp>
+        <p:nvSpPr>
+          <p:cNvPr id="12" name="Werkzeug"/>
+          <p:cNvSpPr/>
+          <p:nvPr/>
+        </p:nvSpPr>
+        <p:spPr>
+          <a:xfrm>
+            <a:off x="548640" y="5336505"/>
+            <a:ext cx="7905750" cy="515655"/>
+          </a:xfrm>
+          <a:prstGeom prst="roundRect">
+            <a:avLst>
+              <a:gd name="adj" fmla="val 3200"/>
+            </a:avLst>
+          </a:prstGeom>
+          <a:solidFill>
+            <a:schemeClr val="bg2"/>
+          </a:solidFill>
+          <a:ln/>
+        </p:spPr>
+        <p:txBody>
+          <a:bodyPr/>
+          <a:p/>
+        </p:txBody>
+      </p:sp>
+      <p:sp>
+        <p:nvSpPr>
+          <p:cNvPr id="13" name="Text 20"/>
+          <p:cNvSpPr txBox="1"/>
+          <p:nvPr/>
+        </p:nvSpPr>
+        <p:spPr>
+          <a:xfrm>
+            <a:off x="731520" y="5409657"/>
+            <a:ext cx="7539990" cy="369351"/>
+          </a:xfrm>
+          <a:prstGeom prst="rect">
+            <a:avLst/>
+          </a:prstGeom>
+          <a:noFill/>
+          <a:ln/>
+        </p:spPr>
+        <p:txBody>
+          <a:bodyPr wrap="square" lIns="0" tIns="0" rIns="0" bIns="0" rtlCol="0" anchor="t"/>
+          <a:lstStyle/>
+          <a:p>
+            <a:pPr indent="0" marL="0">
+              <a:buNone/>
+            </a:pPr>
+            <a:r>
+              <a:rPr lang="en-US" sz="1300" dirty="0">
+                <a:solidFill>
+                  <a:schemeClr val="tx1"/>
+                </a:solidFill>
+              </a:rPr>
+              <a:t>Lesen von links nach rechts: Eingang (Formular oder Chat) → Fakten im Code → vier Prüfer → Ampel → Protokoll in Supabase → Antwort an das Formular.</a:t>
+            </a:r>
+            <a:endParaRPr lang="en-US" sz="1400" dirty="0"/>
+          </a:p>
+        </p:txBody>
+      </p:sp>
+      <p:pic>
+        <p:nvPicPr>
+          <p:cNvPr id="14" name="Screenshot n8n Workflow" descr="n8n-workflow.png"/>
+          <p:cNvPicPr>
+            <a:picLocks noChangeAspect="1"/>
+          </p:cNvPicPr>
+          <p:nvPr/>
+        </p:nvPicPr>
+        <p:blipFill>
+          <a:blip r:embed="rId3"/>
+          <a:stretch>
+            <a:fillRect/>
+          </a:stretch>
+        </p:blipFill>
+        <p:spPr>
+          <a:xfrm>
+            <a:off x="548640" y="1325880"/>
+            <a:ext cx="7905750" cy="3919185"/>
+          </a:xfrm>
+          <a:prstGeom prst="rect">
+            <a:avLst/>
+          </a:prstGeom>
+          <a:ln w="9525">
+            <a:solidFill>
+              <a:srgbClr val="C9D3D0"/>
+            </a:solidFill>
+          </a:ln>
+        </p:spPr>
+      </p:pic>
+    </p:spTree>
+  </p:cSld>
+  <p:clrMapOvr>
+    <a:masterClrMapping/>
+  </p:clrMapOvr>
+</p:sld>
+</file>
+
+<file path=ppt/slides/slide23.xml><?xml version="1.0" encoding="utf-8"?>
 <p:sld xmlns:a="http://schemas.openxmlformats.org/drawingml/2006/main" xmlns:r="http://schemas.openxmlformats.org/officeDocument/2006/relationships" xmlns:p="http://schemas.openxmlformats.org/presentationml/2006/main">
   <p:cSld name="Slide 22">
     <p:spTree>
@@ -27158,7 +27675,7 @@
 </p:sld>
 </file>
 
-<file path=ppt/slides/slide23.xml><?xml version="1.0" encoding="utf-8"?>
+<file path=ppt/slides/slide24.xml><?xml version="1.0" encoding="utf-8"?>
 <p:sld xmlns:a="http://schemas.openxmlformats.org/drawingml/2006/main" xmlns:r="http://schemas.openxmlformats.org/officeDocument/2006/relationships" xmlns:p="http://schemas.openxmlformats.org/presentationml/2006/main">
   <p:cSld name="Slide 23">
     <p:spTree>
@@ -28833,7 +29350,7 @@
 </p:sld>
 </file>
 
-<file path=ppt/slides/slide24.xml><?xml version="1.0" encoding="utf-8"?>
+<file path=ppt/slides/slide25.xml><?xml version="1.0" encoding="utf-8"?>
 <p:sld xmlns:a="http://schemas.openxmlformats.org/drawingml/2006/main" xmlns:r="http://schemas.openxmlformats.org/officeDocument/2006/relationships" xmlns:p="http://schemas.openxmlformats.org/presentationml/2006/main">
   <p:cSld name="Slide 24">
     <p:spTree>
@@ -29862,7 +30379,7 @@
 </p:sld>
 </file>
 
-<file path=ppt/slides/slide25.xml><?xml version="1.0" encoding="utf-8"?>
+<file path=ppt/slides/slide26.xml><?xml version="1.0" encoding="utf-8"?>
 <p:sld xmlns:a="http://schemas.openxmlformats.org/drawingml/2006/main" xmlns:r="http://schemas.openxmlformats.org/officeDocument/2006/relationships" xmlns:p="http://schemas.openxmlformats.org/presentationml/2006/main">
   <p:cSld name="Slide 25">
     <p:spTree>
@@ -31395,7 +31912,7 @@
 </p:sld>
 </file>
 
-<file path=ppt/slides/slide26.xml><?xml version="1.0" encoding="utf-8"?>
+<file path=ppt/slides/slide27.xml><?xml version="1.0" encoding="utf-8"?>
 <p:sld xmlns:a="http://schemas.openxmlformats.org/drawingml/2006/main" xmlns:r="http://schemas.openxmlformats.org/officeDocument/2006/relationships" xmlns:p="http://schemas.openxmlformats.org/presentationml/2006/main">
   <p:cSld name="Slide 26">
     <p:spTree>
@@ -33328,7 +33845,7 @@
 </p:sld>
 </file>
 
-<file path=ppt/slides/slide27.xml><?xml version="1.0" encoding="utf-8"?>
+<file path=ppt/slides/slide28.xml><?xml version="1.0" encoding="utf-8"?>
 <p:sld xmlns:a="http://schemas.openxmlformats.org/drawingml/2006/main" xmlns:r="http://schemas.openxmlformats.org/officeDocument/2006/relationships" xmlns:p="http://schemas.openxmlformats.org/presentationml/2006/main">
   <p:cSld name="Slide 27">
     <p:spTree>
@@ -35096,7 +35613,7 @@
 </p:sld>
 </file>
 
-<file path=ppt/slides/slide28.xml><?xml version="1.0" encoding="utf-8"?>
+<file path=ppt/slides/slide29.xml><?xml version="1.0" encoding="utf-8"?>
 <p:sld xmlns:a="http://schemas.openxmlformats.org/drawingml/2006/main" xmlns:r="http://schemas.openxmlformats.org/officeDocument/2006/relationships" xmlns:p="http://schemas.openxmlformats.org/presentationml/2006/main">
   <p:cSld name="Slide 28">
     <p:spTree>
@@ -36542,7 +37059,1076 @@
 </p:sld>
 </file>
 
-<file path=ppt/slides/slide29.xml><?xml version="1.0" encoding="utf-8"?>
+<file path=ppt/slides/slide3.xml><?xml version="1.0" encoding="utf-8"?>
+<p:sld xmlns:a="http://schemas.openxmlformats.org/drawingml/2006/main" xmlns:r="http://schemas.openxmlformats.org/officeDocument/2006/relationships" xmlns:p="http://schemas.openxmlformats.org/presentationml/2006/main">
+  <p:cSld name="Slide 3">
+    <p:spTree>
+      <p:nvGrpSpPr>
+        <p:cNvPr id="1" name=""/>
+        <p:cNvGrpSpPr/>
+        <p:nvPr/>
+      </p:nvGrpSpPr>
+      <p:grpSpPr>
+        <a:xfrm>
+          <a:off x="0" y="0"/>
+          <a:ext cx="0" cy="0"/>
+          <a:chOff x="0" y="0"/>
+          <a:chExt cx="0" cy="0"/>
+        </a:xfrm>
+      </p:grpSpPr>
+      <p:sp>
+        <p:nvSpPr>
+          <p:cNvPr id="2" name="Text 0"/>
+          <p:cNvSpPr/>
+          <p:nvPr>
+            <p:ph idx="100" type="title" hasCustomPrompt="1"/>
+          </p:nvPr>
+        </p:nvSpPr>
+        <p:spPr>
+          <a:xfrm>
+            <a:off x="548640" y="347472"/>
+            <a:ext cx="9326880" cy="685800"/>
+          </a:xfrm>
+          <a:prstGeom prst="rect">
+            <a:avLst/>
+          </a:prstGeom>
+          <a:noFill/>
+          <a:ln/>
+        </p:spPr>
+        <p:txBody>
+          <a:bodyPr wrap="square" lIns="0" tIns="0" rIns="0" bIns="0" rtlCol="0" anchor="ctr"/>
+          <a:lstStyle/>
+          <a:p>
+            <a:pPr algn="l" indent="0" marL="0">
+              <a:buNone/>
+            </a:pPr>
+            <a:r>
+              <a:rPr lang="en-US" sz="2800" b="1" dirty="0">
+                <a:solidFill>
+                  <a:schemeClr val="tx2"/>
+                </a:solidFill>
+                <a:latin typeface="Cambria" pitchFamily="34" charset="0"/>
+                <a:ea typeface="Cambria" pitchFamily="34" charset="-122"/>
+                <a:cs typeface="Cambria" pitchFamily="34" charset="-120"/>
+              </a:rPr>
+              <a:t>Das Unternehmen: Physiotherapie im GKV-System</a:t>
+            </a:r>
+            <a:endParaRPr lang="en-US" sz="2800" dirty="0"/>
+          </a:p>
+        </p:txBody>
+      </p:sp>
+      <p:sp>
+        <p:nvSpPr>
+          <p:cNvPr id="3" name="Rolleninhaber"/>
+          <p:cNvSpPr/>
+          <p:nvPr/>
+        </p:nvSpPr>
+        <p:spPr>
+          <a:xfrm>
+            <a:off x="10195560" y="457200"/>
+            <a:ext cx="1463040" cy="438912"/>
+          </a:xfrm>
+          <a:prstGeom prst="roundRect">
+            <a:avLst>
+              <a:gd name="adj" fmla="val 50000"/>
+            </a:avLst>
+          </a:prstGeom>
+          <a:solidFill>
+            <a:schemeClr val="tx2"/>
+          </a:solidFill>
+          <a:ln/>
+        </p:spPr>
+        <p:txBody>
+          <a:bodyPr/>
+          <a:p/>
+        </p:txBody>
+      </p:sp>
+      <p:pic>
+        <p:nvPicPr>
+          <p:cNvPr id="4" name="Personen-Symbol" descr="preencoded.png">    </p:cNvPr>
+          <p:cNvPicPr>
+            <a:picLocks noChangeAspect="1"/>
+          </p:cNvPicPr>
+          <p:nvPr/>
+        </p:nvPicPr>
+        <p:blipFill>
+          <a:blip r:embed="rId1"/>
+          <a:stretch>
+            <a:fillRect/>
+          </a:stretch>
+        </p:blipFill>
+        <p:spPr>
+          <a:xfrm>
+            <a:off x="10332720" y="548640"/>
+            <a:ext cx="256032" cy="256032"/>
+          </a:xfrm>
+          <a:prstGeom prst="rect">
+            <a:avLst/>
+          </a:prstGeom>
+        </p:spPr>
+      </p:pic>
+      <p:sp>
+        <p:nvSpPr>
+          <p:cNvPr id="5" name="Name Rolleninhaber"/>
+          <p:cNvSpPr txBox="1"/>
+          <p:nvPr/>
+        </p:nvSpPr>
+        <p:spPr>
+          <a:xfrm>
+            <a:off x="10625328" y="457200"/>
+            <a:ext cx="960120" cy="438912"/>
+          </a:xfrm>
+          <a:prstGeom prst="rect">
+            <a:avLst/>
+          </a:prstGeom>
+          <a:noFill/>
+          <a:ln/>
+        </p:spPr>
+        <p:txBody>
+          <a:bodyPr wrap="square" lIns="0" tIns="0" rIns="0" bIns="0" rtlCol="0" anchor="ctr"/>
+          <a:lstStyle/>
+          <a:p>
+            <a:pPr indent="0" marL="0">
+              <a:buNone/>
+            </a:pPr>
+            <a:r>
+              <a:rPr lang="en-US" sz="1500" b="1" dirty="0">
+                <a:solidFill>
+                  <a:schemeClr val="bg1"/>
+                </a:solidFill>
+              </a:rPr>
+              <a:t>Thomas</a:t>
+            </a:r>
+            <a:endParaRPr lang="en-US" sz="1500" dirty="0"/>
+          </a:p>
+        </p:txBody>
+      </p:sp>
+      <p:sp>
+        <p:nvSpPr>
+          <p:cNvPr id="6" name="Kennzahl"/>
+          <p:cNvSpPr/>
+          <p:nvPr/>
+        </p:nvSpPr>
+        <p:spPr>
+          <a:xfrm>
+            <a:off x="548640" y="1325880"/>
+            <a:ext cx="3291840" cy="1325880"/>
+          </a:xfrm>
+          <a:prstGeom prst="roundRect">
+            <a:avLst>
+              <a:gd name="adj" fmla="val 5517"/>
+            </a:avLst>
+          </a:prstGeom>
+          <a:solidFill>
+            <a:schemeClr val="bg2"/>
+          </a:solidFill>
+          <a:ln/>
+        </p:spPr>
+        <p:txBody>
+          <a:bodyPr/>
+          <a:p/>
+        </p:txBody>
+      </p:sp>
+      <p:sp>
+        <p:nvSpPr>
+          <p:cNvPr id="7" name="Symbolkreis"/>
+          <p:cNvSpPr/>
+          <p:nvPr/>
+        </p:nvSpPr>
+        <p:spPr>
+          <a:xfrm>
+            <a:off x="731520" y="1527048"/>
+            <a:ext cx="530352" cy="530352"/>
+          </a:xfrm>
+          <a:prstGeom prst="ellipse">
+            <a:avLst/>
+          </a:prstGeom>
+          <a:solidFill>
+            <a:schemeClr val="accent1"/>
+          </a:solidFill>
+          <a:ln/>
+        </p:spPr>
+        <p:txBody>
+          <a:bodyPr/>
+          <a:p/>
+        </p:txBody>
+      </p:sp>
+      <p:pic>
+        <p:nvPicPr>
+          <p:cNvPr id="8" name="Symbol" descr="preencoded.png">    </p:cNvPr>
+          <p:cNvPicPr>
+            <a:picLocks noChangeAspect="1"/>
+          </p:cNvPicPr>
+          <p:nvPr/>
+        </p:nvPicPr>
+        <p:blipFill>
+          <a:blip r:embed="rId2"/>
+          <a:stretch>
+            <a:fillRect/>
+          </a:stretch>
+        </p:blipFill>
+        <p:spPr>
+          <a:xfrm>
+            <a:off x="864108" y="1659636"/>
+            <a:ext cx="265176" cy="265176"/>
+          </a:xfrm>
+          <a:prstGeom prst="rect">
+            <a:avLst/>
+          </a:prstGeom>
+        </p:spPr>
+      </p:pic>
+      <p:sp>
+        <p:nvSpPr>
+          <p:cNvPr id="9" name="Text 5"/>
+          <p:cNvSpPr txBox="1"/>
+          <p:nvPr/>
+        </p:nvSpPr>
+        <p:spPr>
+          <a:xfrm>
+            <a:off x="1417320" y="1435608"/>
+            <a:ext cx="2286000" cy="502920"/>
+          </a:xfrm>
+          <a:prstGeom prst="rect">
+            <a:avLst/>
+          </a:prstGeom>
+          <a:noFill/>
+          <a:ln/>
+        </p:spPr>
+        <p:txBody>
+          <a:bodyPr wrap="square" lIns="0" tIns="0" rIns="0" bIns="0" rtlCol="0" anchor="t"/>
+          <a:lstStyle/>
+          <a:p>
+            <a:pPr indent="0" marL="0">
+              <a:buNone/>
+            </a:pPr>
+            <a:r>
+              <a:rPr lang="en-US" sz="2800" b="1" dirty="0">
+                <a:solidFill>
+                  <a:schemeClr val="tx2"/>
+                </a:solidFill>
+                <a:latin typeface="Cambria" pitchFamily="34" charset="0"/>
+                <a:ea typeface="Cambria" pitchFamily="34" charset="-122"/>
+                <a:cs typeface="Cambria" pitchFamily="34" charset="-120"/>
+              </a:rPr>
+              <a:t>2 Praxen</a:t>
+            </a:r>
+            <a:endParaRPr lang="en-US" sz="2800" dirty="0"/>
+          </a:p>
+        </p:txBody>
+      </p:sp>
+      <p:sp>
+        <p:nvSpPr>
+          <p:cNvPr id="10" name="Text 6"/>
+          <p:cNvSpPr txBox="1"/>
+          <p:nvPr/>
+        </p:nvSpPr>
+        <p:spPr>
+          <a:xfrm>
+            <a:off x="1417320" y="1965960"/>
+            <a:ext cx="2331720" cy="594360"/>
+          </a:xfrm>
+          <a:prstGeom prst="rect">
+            <a:avLst/>
+          </a:prstGeom>
+          <a:noFill/>
+          <a:ln/>
+        </p:spPr>
+        <p:txBody>
+          <a:bodyPr wrap="square" lIns="0" tIns="0" rIns="0" bIns="0" rtlCol="0" anchor="t"/>
+          <a:lstStyle/>
+          <a:p>
+            <a:pPr indent="0" marL="0">
+              <a:buNone/>
+            </a:pPr>
+            <a:r>
+              <a:rPr lang="en-US" sz="1200" dirty="0">
+                <a:solidFill>
+                  <a:schemeClr val="tx1"/>
+                </a:solidFill>
+              </a:rPr>
+              <a:t>ca. 10 Mitarbeitende; GKV und privat getrennt, Terminvergabe zentral</a:t>
+            </a:r>
+            <a:endParaRPr lang="en-US" sz="1200" dirty="0"/>
+          </a:p>
+        </p:txBody>
+      </p:sp>
+      <p:sp>
+        <p:nvSpPr>
+          <p:cNvPr id="11" name="Kennzahl"/>
+          <p:cNvSpPr/>
+          <p:nvPr/>
+        </p:nvSpPr>
+        <p:spPr>
+          <a:xfrm>
+            <a:off x="4023360" y="1325880"/>
+            <a:ext cx="3291840" cy="1325880"/>
+          </a:xfrm>
+          <a:prstGeom prst="roundRect">
+            <a:avLst>
+              <a:gd name="adj" fmla="val 5517"/>
+            </a:avLst>
+          </a:prstGeom>
+          <a:solidFill>
+            <a:schemeClr val="bg2"/>
+          </a:solidFill>
+          <a:ln/>
+        </p:spPr>
+        <p:txBody>
+          <a:bodyPr/>
+          <a:p/>
+        </p:txBody>
+      </p:sp>
+      <p:sp>
+        <p:nvSpPr>
+          <p:cNvPr id="12" name="Symbolkreis"/>
+          <p:cNvSpPr/>
+          <p:nvPr/>
+        </p:nvSpPr>
+        <p:spPr>
+          <a:xfrm>
+            <a:off x="4206240" y="1527048"/>
+            <a:ext cx="530352" cy="530352"/>
+          </a:xfrm>
+          <a:prstGeom prst="ellipse">
+            <a:avLst/>
+          </a:prstGeom>
+          <a:solidFill>
+            <a:schemeClr val="accent1"/>
+          </a:solidFill>
+          <a:ln/>
+        </p:spPr>
+        <p:txBody>
+          <a:bodyPr/>
+          <a:p/>
+        </p:txBody>
+      </p:sp>
+      <p:pic>
+        <p:nvPicPr>
+          <p:cNvPr id="13" name="Symbol" descr="preencoded.png">    </p:cNvPr>
+          <p:cNvPicPr>
+            <a:picLocks noChangeAspect="1"/>
+          </p:cNvPicPr>
+          <p:nvPr/>
+        </p:nvPicPr>
+        <p:blipFill>
+          <a:blip r:embed="rId3"/>
+          <a:stretch>
+            <a:fillRect/>
+          </a:stretch>
+        </p:blipFill>
+        <p:spPr>
+          <a:xfrm>
+            <a:off x="4338828" y="1659636"/>
+            <a:ext cx="265176" cy="265176"/>
+          </a:xfrm>
+          <a:prstGeom prst="rect">
+            <a:avLst/>
+          </a:prstGeom>
+        </p:spPr>
+      </p:pic>
+      <p:sp>
+        <p:nvSpPr>
+          <p:cNvPr id="14" name="Text 9"/>
+          <p:cNvSpPr txBox="1"/>
+          <p:nvPr/>
+        </p:nvSpPr>
+        <p:spPr>
+          <a:xfrm>
+            <a:off x="4892040" y="1435608"/>
+            <a:ext cx="2286000" cy="502920"/>
+          </a:xfrm>
+          <a:prstGeom prst="rect">
+            <a:avLst/>
+          </a:prstGeom>
+          <a:noFill/>
+          <a:ln/>
+        </p:spPr>
+        <p:txBody>
+          <a:bodyPr wrap="square" lIns="0" tIns="0" rIns="0" bIns="0" rtlCol="0" anchor="t"/>
+          <a:lstStyle/>
+          <a:p>
+            <a:pPr indent="0" marL="0">
+              <a:buNone/>
+            </a:pPr>
+            <a:r>
+              <a:rPr lang="en-US" sz="2800" b="1" dirty="0">
+                <a:solidFill>
+                  <a:schemeClr val="tx2"/>
+                </a:solidFill>
+                <a:latin typeface="Cambria" pitchFamily="34" charset="0"/>
+                <a:ea typeface="Cambria" pitchFamily="34" charset="-122"/>
+                <a:cs typeface="Cambria" pitchFamily="34" charset="-120"/>
+              </a:rPr>
+              <a:t>ca. 40</a:t>
+            </a:r>
+            <a:endParaRPr lang="en-US" sz="2800" dirty="0"/>
+          </a:p>
+        </p:txBody>
+      </p:sp>
+      <p:sp>
+        <p:nvSpPr>
+          <p:cNvPr id="15" name="Text 10"/>
+          <p:cNvSpPr txBox="1"/>
+          <p:nvPr/>
+        </p:nvSpPr>
+        <p:spPr>
+          <a:xfrm>
+            <a:off x="4892040" y="1965960"/>
+            <a:ext cx="2331720" cy="594360"/>
+          </a:xfrm>
+          <a:prstGeom prst="rect">
+            <a:avLst/>
+          </a:prstGeom>
+          <a:noFill/>
+          <a:ln/>
+        </p:spPr>
+        <p:txBody>
+          <a:bodyPr wrap="square" lIns="0" tIns="0" rIns="0" bIns="0" rtlCol="0" anchor="t"/>
+          <a:lstStyle/>
+          <a:p>
+            <a:pPr indent="0" marL="0">
+              <a:buNone/>
+            </a:pPr>
+            <a:r>
+              <a:rPr lang="en-US" sz="1200" dirty="0">
+                <a:solidFill>
+                  <a:schemeClr val="tx1"/>
+                </a:solidFill>
+              </a:rPr>
+              <a:t>neue Kassenverordnungen pro Woche</a:t>
+            </a:r>
+            <a:endParaRPr lang="en-US" sz="1200" dirty="0"/>
+          </a:p>
+        </p:txBody>
+      </p:sp>
+      <p:sp>
+        <p:nvSpPr>
+          <p:cNvPr id="16" name="Kennzahl"/>
+          <p:cNvSpPr/>
+          <p:nvPr/>
+        </p:nvSpPr>
+        <p:spPr>
+          <a:xfrm>
+            <a:off x="548640" y="2807208"/>
+            <a:ext cx="3291840" cy="1325880"/>
+          </a:xfrm>
+          <a:prstGeom prst="roundRect">
+            <a:avLst>
+              <a:gd name="adj" fmla="val 5517"/>
+            </a:avLst>
+          </a:prstGeom>
+          <a:solidFill>
+            <a:schemeClr val="bg2"/>
+          </a:solidFill>
+          <a:ln/>
+        </p:spPr>
+        <p:txBody>
+          <a:bodyPr/>
+          <a:p/>
+        </p:txBody>
+      </p:sp>
+      <p:sp>
+        <p:nvSpPr>
+          <p:cNvPr id="17" name="Symbolkreis"/>
+          <p:cNvSpPr/>
+          <p:nvPr/>
+        </p:nvSpPr>
+        <p:spPr>
+          <a:xfrm>
+            <a:off x="731520" y="3008376"/>
+            <a:ext cx="530352" cy="530352"/>
+          </a:xfrm>
+          <a:prstGeom prst="ellipse">
+            <a:avLst/>
+          </a:prstGeom>
+          <a:solidFill>
+            <a:schemeClr val="accent1"/>
+          </a:solidFill>
+          <a:ln/>
+        </p:spPr>
+        <p:txBody>
+          <a:bodyPr/>
+          <a:p/>
+        </p:txBody>
+      </p:sp>
+      <p:pic>
+        <p:nvPicPr>
+          <p:cNvPr id="18" name="Symbol" descr="preencoded.png">    </p:cNvPr>
+          <p:cNvPicPr>
+            <a:picLocks noChangeAspect="1"/>
+          </p:cNvPicPr>
+          <p:nvPr/>
+        </p:nvPicPr>
+        <p:blipFill>
+          <a:blip r:embed="rId4"/>
+          <a:stretch>
+            <a:fillRect/>
+          </a:stretch>
+        </p:blipFill>
+        <p:spPr>
+          <a:xfrm>
+            <a:off x="864108" y="3140964"/>
+            <a:ext cx="265176" cy="265176"/>
+          </a:xfrm>
+          <a:prstGeom prst="rect">
+            <a:avLst/>
+          </a:prstGeom>
+        </p:spPr>
+      </p:pic>
+      <p:sp>
+        <p:nvSpPr>
+          <p:cNvPr id="19" name="Text 13"/>
+          <p:cNvSpPr txBox="1"/>
+          <p:nvPr/>
+        </p:nvSpPr>
+        <p:spPr>
+          <a:xfrm>
+            <a:off x="1417320" y="2916936"/>
+            <a:ext cx="2286000" cy="502920"/>
+          </a:xfrm>
+          <a:prstGeom prst="rect">
+            <a:avLst/>
+          </a:prstGeom>
+          <a:noFill/>
+          <a:ln/>
+        </p:spPr>
+        <p:txBody>
+          <a:bodyPr wrap="square" lIns="0" tIns="0" rIns="0" bIns="0" rtlCol="0" anchor="t"/>
+          <a:lstStyle/>
+          <a:p>
+            <a:pPr indent="0" marL="0">
+              <a:buNone/>
+            </a:pPr>
+            <a:r>
+              <a:rPr lang="en-US" sz="2800" b="1" dirty="0">
+                <a:solidFill>
+                  <a:schemeClr val="tx2"/>
+                </a:solidFill>
+                <a:latin typeface="Cambria" pitchFamily="34" charset="0"/>
+                <a:ea typeface="Cambria" pitchFamily="34" charset="-122"/>
+                <a:cs typeface="Cambria" pitchFamily="34" charset="-120"/>
+              </a:rPr>
+              <a:t>1,9 %</a:t>
+            </a:r>
+            <a:endParaRPr lang="en-US" sz="2800" dirty="0"/>
+          </a:p>
+        </p:txBody>
+      </p:sp>
+      <p:sp>
+        <p:nvSpPr>
+          <p:cNvPr id="20" name="Text 14"/>
+          <p:cNvSpPr txBox="1"/>
+          <p:nvPr/>
+        </p:nvSpPr>
+        <p:spPr>
+          <a:xfrm>
+            <a:off x="1417320" y="3447288"/>
+            <a:ext cx="2331720" cy="594360"/>
+          </a:xfrm>
+          <a:prstGeom prst="rect">
+            <a:avLst/>
+          </a:prstGeom>
+          <a:noFill/>
+          <a:ln/>
+        </p:spPr>
+        <p:txBody>
+          <a:bodyPr wrap="square" lIns="0" tIns="0" rIns="0" bIns="0" rtlCol="0" anchor="t"/>
+          <a:lstStyle/>
+          <a:p>
+            <a:pPr indent="0" marL="0">
+              <a:buNone/>
+            </a:pPr>
+            <a:r>
+              <a:rPr lang="en-US" sz="1200" dirty="0">
+                <a:solidFill>
+                  <a:schemeClr val="tx1"/>
+                </a:solidFill>
+              </a:rPr>
+              <a:t>vom Umsatz an den externen Abrechnungsdienstleister</a:t>
+            </a:r>
+            <a:endParaRPr lang="en-US" sz="1200" dirty="0"/>
+          </a:p>
+        </p:txBody>
+      </p:sp>
+      <p:sp>
+        <p:nvSpPr>
+          <p:cNvPr id="21" name="Kennzahl"/>
+          <p:cNvSpPr/>
+          <p:nvPr/>
+        </p:nvSpPr>
+        <p:spPr>
+          <a:xfrm>
+            <a:off x="4023360" y="2807208"/>
+            <a:ext cx="3291840" cy="1325880"/>
+          </a:xfrm>
+          <a:prstGeom prst="roundRect">
+            <a:avLst>
+              <a:gd name="adj" fmla="val 5517"/>
+            </a:avLst>
+          </a:prstGeom>
+          <a:solidFill>
+            <a:schemeClr val="bg2"/>
+          </a:solidFill>
+          <a:ln/>
+        </p:spPr>
+        <p:txBody>
+          <a:bodyPr/>
+          <a:p/>
+        </p:txBody>
+      </p:sp>
+      <p:sp>
+        <p:nvSpPr>
+          <p:cNvPr id="22" name="Symbolkreis"/>
+          <p:cNvSpPr/>
+          <p:nvPr/>
+        </p:nvSpPr>
+        <p:spPr>
+          <a:xfrm>
+            <a:off x="4206240" y="3008376"/>
+            <a:ext cx="530352" cy="530352"/>
+          </a:xfrm>
+          <a:prstGeom prst="ellipse">
+            <a:avLst/>
+          </a:prstGeom>
+          <a:solidFill>
+            <a:schemeClr val="accent1"/>
+          </a:solidFill>
+          <a:ln/>
+        </p:spPr>
+        <p:txBody>
+          <a:bodyPr/>
+          <a:p/>
+        </p:txBody>
+      </p:sp>
+      <p:pic>
+        <p:nvPicPr>
+          <p:cNvPr id="23" name="Symbol" descr="preencoded.png">    </p:cNvPr>
+          <p:cNvPicPr>
+            <a:picLocks noChangeAspect="1"/>
+          </p:cNvPicPr>
+          <p:nvPr/>
+        </p:nvPicPr>
+        <p:blipFill>
+          <a:blip r:embed="rId5"/>
+          <a:stretch>
+            <a:fillRect/>
+          </a:stretch>
+        </p:blipFill>
+        <p:spPr>
+          <a:xfrm>
+            <a:off x="4338828" y="3140964"/>
+            <a:ext cx="265176" cy="265176"/>
+          </a:xfrm>
+          <a:prstGeom prst="rect">
+            <a:avLst/>
+          </a:prstGeom>
+        </p:spPr>
+      </p:pic>
+      <p:sp>
+        <p:nvSpPr>
+          <p:cNvPr id="24" name="Text 17"/>
+          <p:cNvSpPr txBox="1"/>
+          <p:nvPr/>
+        </p:nvSpPr>
+        <p:spPr>
+          <a:xfrm>
+            <a:off x="4892040" y="2916936"/>
+            <a:ext cx="2286000" cy="502920"/>
+          </a:xfrm>
+          <a:prstGeom prst="rect">
+            <a:avLst/>
+          </a:prstGeom>
+          <a:noFill/>
+          <a:ln/>
+        </p:spPr>
+        <p:txBody>
+          <a:bodyPr wrap="square" lIns="0" tIns="0" rIns="0" bIns="0" rtlCol="0" anchor="t"/>
+          <a:lstStyle/>
+          <a:p>
+            <a:pPr indent="0" marL="0">
+              <a:buNone/>
+            </a:pPr>
+            <a:r>
+              <a:rPr lang="en-US" sz="2800" b="1" dirty="0">
+                <a:solidFill>
+                  <a:schemeClr val="tx2"/>
+                </a:solidFill>
+                <a:latin typeface="Cambria" pitchFamily="34" charset="0"/>
+                <a:ea typeface="Cambria" pitchFamily="34" charset="-122"/>
+                <a:cs typeface="Cambria" pitchFamily="34" charset="-120"/>
+              </a:rPr>
+              <a:t>keine KI</a:t>
+            </a:r>
+            <a:endParaRPr lang="en-US" sz="2800" dirty="0"/>
+          </a:p>
+        </p:txBody>
+      </p:sp>
+      <p:sp>
+        <p:nvSpPr>
+          <p:cNvPr id="25" name="Text 18"/>
+          <p:cNvSpPr txBox="1"/>
+          <p:nvPr/>
+        </p:nvSpPr>
+        <p:spPr>
+          <a:xfrm>
+            <a:off x="4892040" y="3447288"/>
+            <a:ext cx="2331720" cy="594360"/>
+          </a:xfrm>
+          <a:prstGeom prst="rect">
+            <a:avLst/>
+          </a:prstGeom>
+          <a:noFill/>
+          <a:ln/>
+        </p:spPr>
+        <p:txBody>
+          <a:bodyPr wrap="square" lIns="0" tIns="0" rIns="0" bIns="0" rtlCol="0" anchor="t"/>
+          <a:lstStyle/>
+          <a:p>
+            <a:pPr indent="0" marL="0">
+              <a:buNone/>
+            </a:pPr>
+            <a:r>
+              <a:rPr lang="en-US" sz="1200" dirty="0">
+                <a:solidFill>
+                  <a:schemeClr val="tx1"/>
+                </a:solidFill>
+              </a:rPr>
+              <a:t>in keinem Bereich, an keinem Standort</a:t>
+            </a:r>
+            <a:endParaRPr lang="en-US" sz="1200" dirty="0"/>
+          </a:p>
+        </p:txBody>
+      </p:sp>
+      <p:sp>
+        <p:nvSpPr>
+          <p:cNvPr id="26" name="Rahmen"/>
+          <p:cNvSpPr/>
+          <p:nvPr/>
+        </p:nvSpPr>
+        <p:spPr>
+          <a:xfrm>
+            <a:off x="548640" y="4343400"/>
+            <a:ext cx="6766560" cy="1600200"/>
+          </a:xfrm>
+          <a:prstGeom prst="roundRect">
+            <a:avLst>
+              <a:gd name="adj" fmla="val 4571"/>
+            </a:avLst>
+          </a:prstGeom>
+          <a:solidFill>
+            <a:schemeClr val="tx2"/>
+          </a:solidFill>
+          <a:ln/>
+        </p:spPr>
+        <p:txBody>
+          <a:bodyPr/>
+          <a:p/>
+        </p:txBody>
+      </p:sp>
+      <p:sp>
+        <p:nvSpPr>
+          <p:cNvPr id="27" name="Text 20"/>
+          <p:cNvSpPr txBox="1"/>
+          <p:nvPr/>
+        </p:nvSpPr>
+        <p:spPr>
+          <a:xfrm>
+            <a:off x="822960" y="4434840"/>
+            <a:ext cx="6217920" cy="347472"/>
+          </a:xfrm>
+          <a:prstGeom prst="rect">
+            <a:avLst/>
+          </a:prstGeom>
+          <a:noFill/>
+          <a:ln/>
+        </p:spPr>
+        <p:txBody>
+          <a:bodyPr wrap="square" lIns="0" tIns="0" rIns="0" bIns="0" rtlCol="0" anchor="t"/>
+          <a:lstStyle/>
+          <a:p>
+            <a:pPr indent="0" marL="0">
+              <a:buNone/>
+            </a:pPr>
+            <a:r>
+              <a:rPr lang="en-US" sz="1600" b="1" dirty="0">
+                <a:solidFill>
+                  <a:schemeClr val="bg1"/>
+                </a:solidFill>
+                <a:latin typeface="Cambria" pitchFamily="34" charset="0"/>
+                <a:ea typeface="Cambria" pitchFamily="34" charset="-122"/>
+                <a:cs typeface="Cambria" pitchFamily="34" charset="-120"/>
+              </a:rPr>
+              <a:t>Warum die Verordnung so wichtig ist</a:t>
+            </a:r>
+            <a:endParaRPr lang="en-US" sz="1600" dirty="0"/>
+          </a:p>
+        </p:txBody>
+      </p:sp>
+      <p:sp>
+        <p:nvSpPr>
+          <p:cNvPr id="28" name="Text 21"/>
+          <p:cNvSpPr txBox="1"/>
+          <p:nvPr/>
+        </p:nvSpPr>
+        <p:spPr>
+          <a:xfrm>
+            <a:off x="822960" y="4828032"/>
+            <a:ext cx="6309360" cy="1051560"/>
+          </a:xfrm>
+          <a:prstGeom prst="rect">
+            <a:avLst/>
+          </a:prstGeom>
+          <a:noFill/>
+          <a:ln/>
+        </p:spPr>
+        <p:txBody>
+          <a:bodyPr wrap="square" lIns="0" tIns="0" rIns="0" bIns="0" rtlCol="0" anchor="t"/>
+          <a:lstStyle/>
+          <a:p>
+            <a:pPr marL="177800" indent="-177800">
+              <a:spcAft>
+                <a:spcPts val="500"/>
+              </a:spcAft>
+              <a:buSzPct val="100000"/>
+              <a:buChar char="•"/>
+            </a:pPr>
+            <a:r>
+              <a:rPr lang="en-US" sz="1300" dirty="0">
+                <a:solidFill>
+                  <a:schemeClr val="bg1"/>
+                </a:solidFill>
+              </a:rPr>
+              <a:t>Jede Kassenbehandlung braucht eine gültige Verordnung auf Muster 13.</a:t>
+            </a:r>
+            <a:endParaRPr lang="en-US" sz="1400" dirty="0"/>
+          </a:p>
+          <a:p>
+            <a:pPr marL="177800" indent="-177800">
+              <a:spcAft>
+                <a:spcPts val="500"/>
+              </a:spcAft>
+              <a:buSzPct val="100000"/>
+              <a:buChar char="•"/>
+            </a:pPr>
+            <a:r>
+              <a:rPr lang="en-US" sz="1300" dirty="0">
+                <a:solidFill>
+                  <a:schemeClr val="bg1"/>
+                </a:solidFill>
+              </a:rPr>
+              <a:t>Was gültig ist, regeln öffentliche Regelwerke von G-BA und KBV.</a:t>
+            </a:r>
+            <a:endParaRPr lang="en-US" sz="1400" dirty="0"/>
+          </a:p>
+          <a:p>
+            <a:pPr marL="177800" indent="-177800">
+              <a:spcAft>
+                <a:spcPts val="500"/>
+              </a:spcAft>
+              <a:buSzPct val="100000"/>
+              <a:buChar char="•"/>
+            </a:pPr>
+            <a:r>
+              <a:rPr lang="en-US" sz="1300" dirty="0">
+                <a:solidFill>
+                  <a:schemeClr val="bg1"/>
+                </a:solidFill>
+              </a:rPr>
+              <a:t>Fehler entdeckt? Dann kürzt die Kasse die Vergütung (Absetzung).</a:t>
+            </a:r>
+            <a:endParaRPr lang="en-US" sz="1400" dirty="0"/>
+          </a:p>
+        </p:txBody>
+      </p:sp>
+      <p:sp>
+        <p:nvSpPr>
+          <p:cNvPr id="29" name="Muster 13 (Blankoformular mit Feldnummern) Rahmen"/>
+          <p:cNvSpPr/>
+          <p:nvPr/>
+        </p:nvSpPr>
+        <p:spPr>
+          <a:xfrm>
+            <a:off x="8170795" y="1289304"/>
+            <a:ext cx="2888243" cy="4325112"/>
+          </a:xfrm>
+          <a:prstGeom prst="rect">
+            <a:avLst/>
+          </a:prstGeom>
+          <a:solidFill>
+            <a:srgbClr val="FFFFFF"/>
+          </a:solidFill>
+          <a:ln w="9525">
+            <a:solidFill>
+              <a:srgbClr val="C9D6D3"/>
+            </a:solidFill>
+            <a:prstDash val="solid"/>
+          </a:ln>
+          <a:effectLst>
+            <a:outerShdw sx="100000" sy="100000" kx="0" ky="0" algn="bl" rotWithShape="0" blurRad="50800" dist="25400" dir="5400000">
+              <a:srgbClr val="000000">
+                <a:alpha val="18000"/>
+              </a:srgbClr>
+            </a:outerShdw>
+          </a:effectLst>
+        </p:spPr>
+        <p:txBody>
+          <a:bodyPr/>
+          <a:p/>
+        </p:txBody>
+      </p:sp>
+      <p:pic>
+        <p:nvPicPr>
+          <p:cNvPr id="30" name="Muster 13 (Blankoformular mit Feldnummern)" descr="Muster 13 (Blankoformular mit Feldnummern)">    </p:cNvPr>
+          <p:cNvPicPr>
+            <a:picLocks noChangeAspect="1"/>
+          </p:cNvPicPr>
+          <p:nvPr/>
+        </p:nvPicPr>
+        <p:blipFill>
+          <a:blip r:embed="rId6"/>
+          <a:stretch>
+            <a:fillRect/>
+          </a:stretch>
+        </p:blipFill>
+        <p:spPr>
+          <a:xfrm>
+            <a:off x="8207371" y="1325880"/>
+            <a:ext cx="2815091" cy="4251960"/>
+          </a:xfrm>
+          <a:prstGeom prst="rect">
+            <a:avLst/>
+          </a:prstGeom>
+        </p:spPr>
+      </p:pic>
+      <p:sp>
+        <p:nvSpPr>
+          <p:cNvPr id="31" name="Text 23"/>
+          <p:cNvSpPr txBox="1"/>
+          <p:nvPr/>
+        </p:nvSpPr>
+        <p:spPr>
+          <a:xfrm>
+            <a:off x="7452360" y="5650992"/>
+            <a:ext cx="4325112" cy="292608"/>
+          </a:xfrm>
+          <a:prstGeom prst="rect">
+            <a:avLst/>
+          </a:prstGeom>
+          <a:noFill/>
+          <a:ln/>
+        </p:spPr>
+        <p:txBody>
+          <a:bodyPr wrap="square" lIns="0" tIns="0" rIns="0" bIns="0" rtlCol="0" anchor="t"/>
+          <a:lstStyle/>
+          <a:p>
+            <a:pPr algn="ctr" indent="0" marL="0">
+              <a:buNone/>
+            </a:pPr>
+            <a:r>
+              <a:rPr lang="en-US" sz="1100" i="1" dirty="0">
+                <a:solidFill>
+                  <a:schemeClr val="accent5"/>
+                </a:solidFill>
+              </a:rPr>
+              <a:t>Muster 13: Diese Felder prüft die Rezeption heute von Hand</a:t>
+            </a:r>
+            <a:endParaRPr lang="en-US" sz="1100" dirty="0"/>
+          </a:p>
+        </p:txBody>
+      </p:sp>
+      <p:sp>
+        <p:nvSpPr>
+          <p:cNvPr id="32" name="Text 24"/>
+          <p:cNvSpPr txBox="1"/>
+          <p:nvPr/>
+        </p:nvSpPr>
+        <p:spPr>
+          <a:xfrm>
+            <a:off x="548640" y="6035040"/>
+            <a:ext cx="11064240" cy="329184"/>
+          </a:xfrm>
+          <a:prstGeom prst="rect">
+            <a:avLst/>
+          </a:prstGeom>
+          <a:noFill/>
+          <a:ln/>
+        </p:spPr>
+        <p:txBody>
+          <a:bodyPr wrap="square" lIns="0" tIns="0" rIns="0" bIns="0" rtlCol="0" anchor="t"/>
+          <a:lstStyle/>
+          <a:p>
+            <a:pPr indent="0" marL="0">
+              <a:buNone/>
+            </a:pPr>
+            <a:r>
+              <a:rPr lang="en-US" sz="1000" i="1" dirty="0">
+                <a:solidFill>
+                  <a:schemeClr val="accent5"/>
+                </a:solidFill>
+              </a:rPr>
+              <a:t>Quellen: Field Study 16.10.2026 und Nachtrag 23.10.2026 · Bild: KV Sachsen-Anhalt, Ausfüllhilfe Muster 13, Stand 01.01.2021 (Blankoformular)</a:t>
+            </a:r>
+            <a:endParaRPr lang="en-US" sz="1000" dirty="0"/>
+          </a:p>
+        </p:txBody>
+      </p:sp>
+      <p:sp>
+        <p:nvSpPr>
+          <p:cNvPr id="25" name="Slide Number Placeholder 0"/>
+          <p:cNvSpPr>
+            <a:spLocks noGrp="1"/>
+          </p:cNvSpPr>
+          <p:nvPr>
+            <p:ph type="sldNum" sz="quarter" idx="4294967295"/>
+          </p:nvPr>
+        </p:nvSpPr>
+        <p:spPr>
+          <a:xfrm>
+            <a:off x="11201400" y="6419088"/>
+            <a:ext cx="457200" cy="274320"/>
+          </a:xfrm>
+          <a:prstGeom prst="rect">
+            <a:avLst/>
+          </a:prstGeom>
+          <a:extLst>
+            <a:ext uri="{C572A759-6A51-4108-AA02-DFA0A04FC94B}">
+              <ma14:wrappingTextBoxFlag xmlns:ma14="http://schemas.microsoft.com/office/mac/drawingml/2011/main" val="0"/>
+            </a:ext>
+          </a:extLst>
+        </p:spPr>
+        <p:txBody>
+          <a:bodyPr/>
+          <a:lstStyle>
+            <a:lvl1pPr>
+              <a:defRPr sz="1000">
+                <a:solidFill>
+                  <a:schemeClr val="accent5"/>
+                </a:solidFill>
+                <a:latin typeface="Calibri"/>
+                <a:ea typeface="Calibri"/>
+                <a:cs typeface="Calibri"/>
+              </a:defRPr>
+            </a:lvl1pPr>
+          </a:lstStyle>
+          <a:p>
+            <a:pPr algn="r"/>
+            <a:fld id="{F7021451-1387-4CA6-816F-3879F97B5CBC}" type="slidenum">
+              <a:rPr b="0" lang="en-US"/>
+              <a:t>3</a:t>
+            </a:fld>
+            <a:endParaRPr lang="en-US"/>
+          </a:p>
+        </p:txBody>
+      </p:sp>
+    </p:spTree>
+  </p:cSld>
+  <p:clrMapOvr>
+    <a:masterClrMapping/>
+  </p:clrMapOvr>
+</p:sld>
+</file>
+
+<file path=ppt/slides/slide30.xml><?xml version="1.0" encoding="utf-8"?>
 <p:sld xmlns:a="http://schemas.openxmlformats.org/drawingml/2006/main" xmlns:r="http://schemas.openxmlformats.org/officeDocument/2006/relationships" xmlns:p="http://schemas.openxmlformats.org/presentationml/2006/main">
   <p:cSld name="Slide 29">
     <p:spTree>
@@ -38163,1076 +39749,7 @@
 </p:sld>
 </file>
 
-<file path=ppt/slides/slide3.xml><?xml version="1.0" encoding="utf-8"?>
-<p:sld xmlns:a="http://schemas.openxmlformats.org/drawingml/2006/main" xmlns:r="http://schemas.openxmlformats.org/officeDocument/2006/relationships" xmlns:p="http://schemas.openxmlformats.org/presentationml/2006/main">
-  <p:cSld name="Slide 3">
-    <p:spTree>
-      <p:nvGrpSpPr>
-        <p:cNvPr id="1" name=""/>
-        <p:cNvGrpSpPr/>
-        <p:nvPr/>
-      </p:nvGrpSpPr>
-      <p:grpSpPr>
-        <a:xfrm>
-          <a:off x="0" y="0"/>
-          <a:ext cx="0" cy="0"/>
-          <a:chOff x="0" y="0"/>
-          <a:chExt cx="0" cy="0"/>
-        </a:xfrm>
-      </p:grpSpPr>
-      <p:sp>
-        <p:nvSpPr>
-          <p:cNvPr id="2" name="Text 0"/>
-          <p:cNvSpPr/>
-          <p:nvPr>
-            <p:ph idx="100" type="title" hasCustomPrompt="1"/>
-          </p:nvPr>
-        </p:nvSpPr>
-        <p:spPr>
-          <a:xfrm>
-            <a:off x="548640" y="347472"/>
-            <a:ext cx="9326880" cy="685800"/>
-          </a:xfrm>
-          <a:prstGeom prst="rect">
-            <a:avLst/>
-          </a:prstGeom>
-          <a:noFill/>
-          <a:ln/>
-        </p:spPr>
-        <p:txBody>
-          <a:bodyPr wrap="square" lIns="0" tIns="0" rIns="0" bIns="0" rtlCol="0" anchor="ctr"/>
-          <a:lstStyle/>
-          <a:p>
-            <a:pPr algn="l" indent="0" marL="0">
-              <a:buNone/>
-            </a:pPr>
-            <a:r>
-              <a:rPr lang="en-US" sz="2800" b="1" dirty="0">
-                <a:solidFill>
-                  <a:schemeClr val="tx2"/>
-                </a:solidFill>
-                <a:latin typeface="Cambria" pitchFamily="34" charset="0"/>
-                <a:ea typeface="Cambria" pitchFamily="34" charset="-122"/>
-                <a:cs typeface="Cambria" pitchFamily="34" charset="-120"/>
-              </a:rPr>
-              <a:t>Das Unternehmen: Physiotherapie im GKV-System</a:t>
-            </a:r>
-            <a:endParaRPr lang="en-US" sz="2800" dirty="0"/>
-          </a:p>
-        </p:txBody>
-      </p:sp>
-      <p:sp>
-        <p:nvSpPr>
-          <p:cNvPr id="3" name="Rolleninhaber"/>
-          <p:cNvSpPr/>
-          <p:nvPr/>
-        </p:nvSpPr>
-        <p:spPr>
-          <a:xfrm>
-            <a:off x="10195560" y="457200"/>
-            <a:ext cx="1463040" cy="438912"/>
-          </a:xfrm>
-          <a:prstGeom prst="roundRect">
-            <a:avLst>
-              <a:gd name="adj" fmla="val 50000"/>
-            </a:avLst>
-          </a:prstGeom>
-          <a:solidFill>
-            <a:schemeClr val="tx2"/>
-          </a:solidFill>
-          <a:ln/>
-        </p:spPr>
-        <p:txBody>
-          <a:bodyPr/>
-          <a:p/>
-        </p:txBody>
-      </p:sp>
-      <p:pic>
-        <p:nvPicPr>
-          <p:cNvPr id="4" name="Personen-Symbol" descr="preencoded.png">    </p:cNvPr>
-          <p:cNvPicPr>
-            <a:picLocks noChangeAspect="1"/>
-          </p:cNvPicPr>
-          <p:nvPr/>
-        </p:nvPicPr>
-        <p:blipFill>
-          <a:blip r:embed="rId1"/>
-          <a:stretch>
-            <a:fillRect/>
-          </a:stretch>
-        </p:blipFill>
-        <p:spPr>
-          <a:xfrm>
-            <a:off x="10332720" y="548640"/>
-            <a:ext cx="256032" cy="256032"/>
-          </a:xfrm>
-          <a:prstGeom prst="rect">
-            <a:avLst/>
-          </a:prstGeom>
-        </p:spPr>
-      </p:pic>
-      <p:sp>
-        <p:nvSpPr>
-          <p:cNvPr id="5" name="Name Rolleninhaber"/>
-          <p:cNvSpPr txBox="1"/>
-          <p:nvPr/>
-        </p:nvSpPr>
-        <p:spPr>
-          <a:xfrm>
-            <a:off x="10625328" y="457200"/>
-            <a:ext cx="960120" cy="438912"/>
-          </a:xfrm>
-          <a:prstGeom prst="rect">
-            <a:avLst/>
-          </a:prstGeom>
-          <a:noFill/>
-          <a:ln/>
-        </p:spPr>
-        <p:txBody>
-          <a:bodyPr wrap="square" lIns="0" tIns="0" rIns="0" bIns="0" rtlCol="0" anchor="ctr"/>
-          <a:lstStyle/>
-          <a:p>
-            <a:pPr indent="0" marL="0">
-              <a:buNone/>
-            </a:pPr>
-            <a:r>
-              <a:rPr lang="en-US" sz="1500" b="1" dirty="0">
-                <a:solidFill>
-                  <a:schemeClr val="bg1"/>
-                </a:solidFill>
-              </a:rPr>
-              <a:t>Thomas</a:t>
-            </a:r>
-            <a:endParaRPr lang="en-US" sz="1500" dirty="0"/>
-          </a:p>
-        </p:txBody>
-      </p:sp>
-      <p:sp>
-        <p:nvSpPr>
-          <p:cNvPr id="6" name="Kennzahl"/>
-          <p:cNvSpPr/>
-          <p:nvPr/>
-        </p:nvSpPr>
-        <p:spPr>
-          <a:xfrm>
-            <a:off x="548640" y="1325880"/>
-            <a:ext cx="3291840" cy="1325880"/>
-          </a:xfrm>
-          <a:prstGeom prst="roundRect">
-            <a:avLst>
-              <a:gd name="adj" fmla="val 5517"/>
-            </a:avLst>
-          </a:prstGeom>
-          <a:solidFill>
-            <a:schemeClr val="bg2"/>
-          </a:solidFill>
-          <a:ln/>
-        </p:spPr>
-        <p:txBody>
-          <a:bodyPr/>
-          <a:p/>
-        </p:txBody>
-      </p:sp>
-      <p:sp>
-        <p:nvSpPr>
-          <p:cNvPr id="7" name="Symbolkreis"/>
-          <p:cNvSpPr/>
-          <p:nvPr/>
-        </p:nvSpPr>
-        <p:spPr>
-          <a:xfrm>
-            <a:off x="731520" y="1527048"/>
-            <a:ext cx="530352" cy="530352"/>
-          </a:xfrm>
-          <a:prstGeom prst="ellipse">
-            <a:avLst/>
-          </a:prstGeom>
-          <a:solidFill>
-            <a:schemeClr val="accent1"/>
-          </a:solidFill>
-          <a:ln/>
-        </p:spPr>
-        <p:txBody>
-          <a:bodyPr/>
-          <a:p/>
-        </p:txBody>
-      </p:sp>
-      <p:pic>
-        <p:nvPicPr>
-          <p:cNvPr id="8" name="Symbol" descr="preencoded.png">    </p:cNvPr>
-          <p:cNvPicPr>
-            <a:picLocks noChangeAspect="1"/>
-          </p:cNvPicPr>
-          <p:nvPr/>
-        </p:nvPicPr>
-        <p:blipFill>
-          <a:blip r:embed="rId2"/>
-          <a:stretch>
-            <a:fillRect/>
-          </a:stretch>
-        </p:blipFill>
-        <p:spPr>
-          <a:xfrm>
-            <a:off x="864108" y="1659636"/>
-            <a:ext cx="265176" cy="265176"/>
-          </a:xfrm>
-          <a:prstGeom prst="rect">
-            <a:avLst/>
-          </a:prstGeom>
-        </p:spPr>
-      </p:pic>
-      <p:sp>
-        <p:nvSpPr>
-          <p:cNvPr id="9" name="Text 5"/>
-          <p:cNvSpPr txBox="1"/>
-          <p:nvPr/>
-        </p:nvSpPr>
-        <p:spPr>
-          <a:xfrm>
-            <a:off x="1417320" y="1435608"/>
-            <a:ext cx="2286000" cy="502920"/>
-          </a:xfrm>
-          <a:prstGeom prst="rect">
-            <a:avLst/>
-          </a:prstGeom>
-          <a:noFill/>
-          <a:ln/>
-        </p:spPr>
-        <p:txBody>
-          <a:bodyPr wrap="square" lIns="0" tIns="0" rIns="0" bIns="0" rtlCol="0" anchor="t"/>
-          <a:lstStyle/>
-          <a:p>
-            <a:pPr indent="0" marL="0">
-              <a:buNone/>
-            </a:pPr>
-            <a:r>
-              <a:rPr lang="en-US" sz="2800" b="1" dirty="0">
-                <a:solidFill>
-                  <a:schemeClr val="tx2"/>
-                </a:solidFill>
-                <a:latin typeface="Cambria" pitchFamily="34" charset="0"/>
-                <a:ea typeface="Cambria" pitchFamily="34" charset="-122"/>
-                <a:cs typeface="Cambria" pitchFamily="34" charset="-120"/>
-              </a:rPr>
-              <a:t>2 Praxen</a:t>
-            </a:r>
-            <a:endParaRPr lang="en-US" sz="2800" dirty="0"/>
-          </a:p>
-        </p:txBody>
-      </p:sp>
-      <p:sp>
-        <p:nvSpPr>
-          <p:cNvPr id="10" name="Text 6"/>
-          <p:cNvSpPr txBox="1"/>
-          <p:nvPr/>
-        </p:nvSpPr>
-        <p:spPr>
-          <a:xfrm>
-            <a:off x="1417320" y="1965960"/>
-            <a:ext cx="2331720" cy="594360"/>
-          </a:xfrm>
-          <a:prstGeom prst="rect">
-            <a:avLst/>
-          </a:prstGeom>
-          <a:noFill/>
-          <a:ln/>
-        </p:spPr>
-        <p:txBody>
-          <a:bodyPr wrap="square" lIns="0" tIns="0" rIns="0" bIns="0" rtlCol="0" anchor="t"/>
-          <a:lstStyle/>
-          <a:p>
-            <a:pPr indent="0" marL="0">
-              <a:buNone/>
-            </a:pPr>
-            <a:r>
-              <a:rPr lang="en-US" sz="1200" dirty="0">
-                <a:solidFill>
-                  <a:schemeClr val="tx1"/>
-                </a:solidFill>
-              </a:rPr>
-              <a:t>ca. 10 Mitarbeitende; GKV und privat getrennt, Terminvergabe zentral</a:t>
-            </a:r>
-            <a:endParaRPr lang="en-US" sz="1200" dirty="0"/>
-          </a:p>
-        </p:txBody>
-      </p:sp>
-      <p:sp>
-        <p:nvSpPr>
-          <p:cNvPr id="11" name="Kennzahl"/>
-          <p:cNvSpPr/>
-          <p:nvPr/>
-        </p:nvSpPr>
-        <p:spPr>
-          <a:xfrm>
-            <a:off x="4023360" y="1325880"/>
-            <a:ext cx="3291840" cy="1325880"/>
-          </a:xfrm>
-          <a:prstGeom prst="roundRect">
-            <a:avLst>
-              <a:gd name="adj" fmla="val 5517"/>
-            </a:avLst>
-          </a:prstGeom>
-          <a:solidFill>
-            <a:schemeClr val="bg2"/>
-          </a:solidFill>
-          <a:ln/>
-        </p:spPr>
-        <p:txBody>
-          <a:bodyPr/>
-          <a:p/>
-        </p:txBody>
-      </p:sp>
-      <p:sp>
-        <p:nvSpPr>
-          <p:cNvPr id="12" name="Symbolkreis"/>
-          <p:cNvSpPr/>
-          <p:nvPr/>
-        </p:nvSpPr>
-        <p:spPr>
-          <a:xfrm>
-            <a:off x="4206240" y="1527048"/>
-            <a:ext cx="530352" cy="530352"/>
-          </a:xfrm>
-          <a:prstGeom prst="ellipse">
-            <a:avLst/>
-          </a:prstGeom>
-          <a:solidFill>
-            <a:schemeClr val="accent1"/>
-          </a:solidFill>
-          <a:ln/>
-        </p:spPr>
-        <p:txBody>
-          <a:bodyPr/>
-          <a:p/>
-        </p:txBody>
-      </p:sp>
-      <p:pic>
-        <p:nvPicPr>
-          <p:cNvPr id="13" name="Symbol" descr="preencoded.png">    </p:cNvPr>
-          <p:cNvPicPr>
-            <a:picLocks noChangeAspect="1"/>
-          </p:cNvPicPr>
-          <p:nvPr/>
-        </p:nvPicPr>
-        <p:blipFill>
-          <a:blip r:embed="rId3"/>
-          <a:stretch>
-            <a:fillRect/>
-          </a:stretch>
-        </p:blipFill>
-        <p:spPr>
-          <a:xfrm>
-            <a:off x="4338828" y="1659636"/>
-            <a:ext cx="265176" cy="265176"/>
-          </a:xfrm>
-          <a:prstGeom prst="rect">
-            <a:avLst/>
-          </a:prstGeom>
-        </p:spPr>
-      </p:pic>
-      <p:sp>
-        <p:nvSpPr>
-          <p:cNvPr id="14" name="Text 9"/>
-          <p:cNvSpPr txBox="1"/>
-          <p:nvPr/>
-        </p:nvSpPr>
-        <p:spPr>
-          <a:xfrm>
-            <a:off x="4892040" y="1435608"/>
-            <a:ext cx="2286000" cy="502920"/>
-          </a:xfrm>
-          <a:prstGeom prst="rect">
-            <a:avLst/>
-          </a:prstGeom>
-          <a:noFill/>
-          <a:ln/>
-        </p:spPr>
-        <p:txBody>
-          <a:bodyPr wrap="square" lIns="0" tIns="0" rIns="0" bIns="0" rtlCol="0" anchor="t"/>
-          <a:lstStyle/>
-          <a:p>
-            <a:pPr indent="0" marL="0">
-              <a:buNone/>
-            </a:pPr>
-            <a:r>
-              <a:rPr lang="en-US" sz="2800" b="1" dirty="0">
-                <a:solidFill>
-                  <a:schemeClr val="tx2"/>
-                </a:solidFill>
-                <a:latin typeface="Cambria" pitchFamily="34" charset="0"/>
-                <a:ea typeface="Cambria" pitchFamily="34" charset="-122"/>
-                <a:cs typeface="Cambria" pitchFamily="34" charset="-120"/>
-              </a:rPr>
-              <a:t>ca. 40</a:t>
-            </a:r>
-            <a:endParaRPr lang="en-US" sz="2800" dirty="0"/>
-          </a:p>
-        </p:txBody>
-      </p:sp>
-      <p:sp>
-        <p:nvSpPr>
-          <p:cNvPr id="15" name="Text 10"/>
-          <p:cNvSpPr txBox="1"/>
-          <p:nvPr/>
-        </p:nvSpPr>
-        <p:spPr>
-          <a:xfrm>
-            <a:off x="4892040" y="1965960"/>
-            <a:ext cx="2331720" cy="594360"/>
-          </a:xfrm>
-          <a:prstGeom prst="rect">
-            <a:avLst/>
-          </a:prstGeom>
-          <a:noFill/>
-          <a:ln/>
-        </p:spPr>
-        <p:txBody>
-          <a:bodyPr wrap="square" lIns="0" tIns="0" rIns="0" bIns="0" rtlCol="0" anchor="t"/>
-          <a:lstStyle/>
-          <a:p>
-            <a:pPr indent="0" marL="0">
-              <a:buNone/>
-            </a:pPr>
-            <a:r>
-              <a:rPr lang="en-US" sz="1200" dirty="0">
-                <a:solidFill>
-                  <a:schemeClr val="tx1"/>
-                </a:solidFill>
-              </a:rPr>
-              <a:t>neue Kassenverordnungen pro Woche</a:t>
-            </a:r>
-            <a:endParaRPr lang="en-US" sz="1200" dirty="0"/>
-          </a:p>
-        </p:txBody>
-      </p:sp>
-      <p:sp>
-        <p:nvSpPr>
-          <p:cNvPr id="16" name="Kennzahl"/>
-          <p:cNvSpPr/>
-          <p:nvPr/>
-        </p:nvSpPr>
-        <p:spPr>
-          <a:xfrm>
-            <a:off x="548640" y="2807208"/>
-            <a:ext cx="3291840" cy="1325880"/>
-          </a:xfrm>
-          <a:prstGeom prst="roundRect">
-            <a:avLst>
-              <a:gd name="adj" fmla="val 5517"/>
-            </a:avLst>
-          </a:prstGeom>
-          <a:solidFill>
-            <a:schemeClr val="bg2"/>
-          </a:solidFill>
-          <a:ln/>
-        </p:spPr>
-        <p:txBody>
-          <a:bodyPr/>
-          <a:p/>
-        </p:txBody>
-      </p:sp>
-      <p:sp>
-        <p:nvSpPr>
-          <p:cNvPr id="17" name="Symbolkreis"/>
-          <p:cNvSpPr/>
-          <p:nvPr/>
-        </p:nvSpPr>
-        <p:spPr>
-          <a:xfrm>
-            <a:off x="731520" y="3008376"/>
-            <a:ext cx="530352" cy="530352"/>
-          </a:xfrm>
-          <a:prstGeom prst="ellipse">
-            <a:avLst/>
-          </a:prstGeom>
-          <a:solidFill>
-            <a:schemeClr val="accent1"/>
-          </a:solidFill>
-          <a:ln/>
-        </p:spPr>
-        <p:txBody>
-          <a:bodyPr/>
-          <a:p/>
-        </p:txBody>
-      </p:sp>
-      <p:pic>
-        <p:nvPicPr>
-          <p:cNvPr id="18" name="Symbol" descr="preencoded.png">    </p:cNvPr>
-          <p:cNvPicPr>
-            <a:picLocks noChangeAspect="1"/>
-          </p:cNvPicPr>
-          <p:nvPr/>
-        </p:nvPicPr>
-        <p:blipFill>
-          <a:blip r:embed="rId4"/>
-          <a:stretch>
-            <a:fillRect/>
-          </a:stretch>
-        </p:blipFill>
-        <p:spPr>
-          <a:xfrm>
-            <a:off x="864108" y="3140964"/>
-            <a:ext cx="265176" cy="265176"/>
-          </a:xfrm>
-          <a:prstGeom prst="rect">
-            <a:avLst/>
-          </a:prstGeom>
-        </p:spPr>
-      </p:pic>
-      <p:sp>
-        <p:nvSpPr>
-          <p:cNvPr id="19" name="Text 13"/>
-          <p:cNvSpPr txBox="1"/>
-          <p:nvPr/>
-        </p:nvSpPr>
-        <p:spPr>
-          <a:xfrm>
-            <a:off x="1417320" y="2916936"/>
-            <a:ext cx="2286000" cy="502920"/>
-          </a:xfrm>
-          <a:prstGeom prst="rect">
-            <a:avLst/>
-          </a:prstGeom>
-          <a:noFill/>
-          <a:ln/>
-        </p:spPr>
-        <p:txBody>
-          <a:bodyPr wrap="square" lIns="0" tIns="0" rIns="0" bIns="0" rtlCol="0" anchor="t"/>
-          <a:lstStyle/>
-          <a:p>
-            <a:pPr indent="0" marL="0">
-              <a:buNone/>
-            </a:pPr>
-            <a:r>
-              <a:rPr lang="en-US" sz="2800" b="1" dirty="0">
-                <a:solidFill>
-                  <a:schemeClr val="tx2"/>
-                </a:solidFill>
-                <a:latin typeface="Cambria" pitchFamily="34" charset="0"/>
-                <a:ea typeface="Cambria" pitchFamily="34" charset="-122"/>
-                <a:cs typeface="Cambria" pitchFamily="34" charset="-120"/>
-              </a:rPr>
-              <a:t>3–6 %</a:t>
-            </a:r>
-            <a:endParaRPr lang="en-US" sz="2800" dirty="0"/>
-          </a:p>
-        </p:txBody>
-      </p:sp>
-      <p:sp>
-        <p:nvSpPr>
-          <p:cNvPr id="20" name="Text 14"/>
-          <p:cNvSpPr txBox="1"/>
-          <p:nvPr/>
-        </p:nvSpPr>
-        <p:spPr>
-          <a:xfrm>
-            <a:off x="1417320" y="3447288"/>
-            <a:ext cx="2331720" cy="594360"/>
-          </a:xfrm>
-          <a:prstGeom prst="rect">
-            <a:avLst/>
-          </a:prstGeom>
-          <a:noFill/>
-          <a:ln/>
-        </p:spPr>
-        <p:txBody>
-          <a:bodyPr wrap="square" lIns="0" tIns="0" rIns="0" bIns="0" rtlCol="0" anchor="t"/>
-          <a:lstStyle/>
-          <a:p>
-            <a:pPr indent="0" marL="0">
-              <a:buNone/>
-            </a:pPr>
-            <a:r>
-              <a:rPr lang="en-US" sz="1200" dirty="0">
-                <a:solidFill>
-                  <a:schemeClr val="tx1"/>
-                </a:solidFill>
-              </a:rPr>
-              <a:t>vom Umsatz an den externen Abrechnungsdienstleister</a:t>
-            </a:r>
-            <a:endParaRPr lang="en-US" sz="1200" dirty="0"/>
-          </a:p>
-        </p:txBody>
-      </p:sp>
-      <p:sp>
-        <p:nvSpPr>
-          <p:cNvPr id="21" name="Kennzahl"/>
-          <p:cNvSpPr/>
-          <p:nvPr/>
-        </p:nvSpPr>
-        <p:spPr>
-          <a:xfrm>
-            <a:off x="4023360" y="2807208"/>
-            <a:ext cx="3291840" cy="1325880"/>
-          </a:xfrm>
-          <a:prstGeom prst="roundRect">
-            <a:avLst>
-              <a:gd name="adj" fmla="val 5517"/>
-            </a:avLst>
-          </a:prstGeom>
-          <a:solidFill>
-            <a:schemeClr val="bg2"/>
-          </a:solidFill>
-          <a:ln/>
-        </p:spPr>
-        <p:txBody>
-          <a:bodyPr/>
-          <a:p/>
-        </p:txBody>
-      </p:sp>
-      <p:sp>
-        <p:nvSpPr>
-          <p:cNvPr id="22" name="Symbolkreis"/>
-          <p:cNvSpPr/>
-          <p:nvPr/>
-        </p:nvSpPr>
-        <p:spPr>
-          <a:xfrm>
-            <a:off x="4206240" y="3008376"/>
-            <a:ext cx="530352" cy="530352"/>
-          </a:xfrm>
-          <a:prstGeom prst="ellipse">
-            <a:avLst/>
-          </a:prstGeom>
-          <a:solidFill>
-            <a:schemeClr val="accent1"/>
-          </a:solidFill>
-          <a:ln/>
-        </p:spPr>
-        <p:txBody>
-          <a:bodyPr/>
-          <a:p/>
-        </p:txBody>
-      </p:sp>
-      <p:pic>
-        <p:nvPicPr>
-          <p:cNvPr id="23" name="Symbol" descr="preencoded.png">    </p:cNvPr>
-          <p:cNvPicPr>
-            <a:picLocks noChangeAspect="1"/>
-          </p:cNvPicPr>
-          <p:nvPr/>
-        </p:nvPicPr>
-        <p:blipFill>
-          <a:blip r:embed="rId5"/>
-          <a:stretch>
-            <a:fillRect/>
-          </a:stretch>
-        </p:blipFill>
-        <p:spPr>
-          <a:xfrm>
-            <a:off x="4338828" y="3140964"/>
-            <a:ext cx="265176" cy="265176"/>
-          </a:xfrm>
-          <a:prstGeom prst="rect">
-            <a:avLst/>
-          </a:prstGeom>
-        </p:spPr>
-      </p:pic>
-      <p:sp>
-        <p:nvSpPr>
-          <p:cNvPr id="24" name="Text 17"/>
-          <p:cNvSpPr txBox="1"/>
-          <p:nvPr/>
-        </p:nvSpPr>
-        <p:spPr>
-          <a:xfrm>
-            <a:off x="4892040" y="2916936"/>
-            <a:ext cx="2286000" cy="502920"/>
-          </a:xfrm>
-          <a:prstGeom prst="rect">
-            <a:avLst/>
-          </a:prstGeom>
-          <a:noFill/>
-          <a:ln/>
-        </p:spPr>
-        <p:txBody>
-          <a:bodyPr wrap="square" lIns="0" tIns="0" rIns="0" bIns="0" rtlCol="0" anchor="t"/>
-          <a:lstStyle/>
-          <a:p>
-            <a:pPr indent="0" marL="0">
-              <a:buNone/>
-            </a:pPr>
-            <a:r>
-              <a:rPr lang="en-US" sz="2800" b="1" dirty="0">
-                <a:solidFill>
-                  <a:schemeClr val="tx2"/>
-                </a:solidFill>
-                <a:latin typeface="Cambria" pitchFamily="34" charset="0"/>
-                <a:ea typeface="Cambria" pitchFamily="34" charset="-122"/>
-                <a:cs typeface="Cambria" pitchFamily="34" charset="-120"/>
-              </a:rPr>
-              <a:t>keine KI</a:t>
-            </a:r>
-            <a:endParaRPr lang="en-US" sz="2800" dirty="0"/>
-          </a:p>
-        </p:txBody>
-      </p:sp>
-      <p:sp>
-        <p:nvSpPr>
-          <p:cNvPr id="25" name="Text 18"/>
-          <p:cNvSpPr txBox="1"/>
-          <p:nvPr/>
-        </p:nvSpPr>
-        <p:spPr>
-          <a:xfrm>
-            <a:off x="4892040" y="3447288"/>
-            <a:ext cx="2331720" cy="594360"/>
-          </a:xfrm>
-          <a:prstGeom prst="rect">
-            <a:avLst/>
-          </a:prstGeom>
-          <a:noFill/>
-          <a:ln/>
-        </p:spPr>
-        <p:txBody>
-          <a:bodyPr wrap="square" lIns="0" tIns="0" rIns="0" bIns="0" rtlCol="0" anchor="t"/>
-          <a:lstStyle/>
-          <a:p>
-            <a:pPr indent="0" marL="0">
-              <a:buNone/>
-            </a:pPr>
-            <a:r>
-              <a:rPr lang="en-US" sz="1200" dirty="0">
-                <a:solidFill>
-                  <a:schemeClr val="tx1"/>
-                </a:solidFill>
-              </a:rPr>
-              <a:t>in keinem Bereich, an keinem Standort</a:t>
-            </a:r>
-            <a:endParaRPr lang="en-US" sz="1200" dirty="0"/>
-          </a:p>
-        </p:txBody>
-      </p:sp>
-      <p:sp>
-        <p:nvSpPr>
-          <p:cNvPr id="26" name="Rahmen"/>
-          <p:cNvSpPr/>
-          <p:nvPr/>
-        </p:nvSpPr>
-        <p:spPr>
-          <a:xfrm>
-            <a:off x="548640" y="4343400"/>
-            <a:ext cx="6766560" cy="1600200"/>
-          </a:xfrm>
-          <a:prstGeom prst="roundRect">
-            <a:avLst>
-              <a:gd name="adj" fmla="val 4571"/>
-            </a:avLst>
-          </a:prstGeom>
-          <a:solidFill>
-            <a:schemeClr val="tx2"/>
-          </a:solidFill>
-          <a:ln/>
-        </p:spPr>
-        <p:txBody>
-          <a:bodyPr/>
-          <a:p/>
-        </p:txBody>
-      </p:sp>
-      <p:sp>
-        <p:nvSpPr>
-          <p:cNvPr id="27" name="Text 20"/>
-          <p:cNvSpPr txBox="1"/>
-          <p:nvPr/>
-        </p:nvSpPr>
-        <p:spPr>
-          <a:xfrm>
-            <a:off x="822960" y="4434840"/>
-            <a:ext cx="6217920" cy="347472"/>
-          </a:xfrm>
-          <a:prstGeom prst="rect">
-            <a:avLst/>
-          </a:prstGeom>
-          <a:noFill/>
-          <a:ln/>
-        </p:spPr>
-        <p:txBody>
-          <a:bodyPr wrap="square" lIns="0" tIns="0" rIns="0" bIns="0" rtlCol="0" anchor="t"/>
-          <a:lstStyle/>
-          <a:p>
-            <a:pPr indent="0" marL="0">
-              <a:buNone/>
-            </a:pPr>
-            <a:r>
-              <a:rPr lang="en-US" sz="1600" b="1" dirty="0">
-                <a:solidFill>
-                  <a:schemeClr val="bg1"/>
-                </a:solidFill>
-                <a:latin typeface="Cambria" pitchFamily="34" charset="0"/>
-                <a:ea typeface="Cambria" pitchFamily="34" charset="-122"/>
-                <a:cs typeface="Cambria" pitchFamily="34" charset="-120"/>
-              </a:rPr>
-              <a:t>Warum die Verordnung so wichtig ist</a:t>
-            </a:r>
-            <a:endParaRPr lang="en-US" sz="1600" dirty="0"/>
-          </a:p>
-        </p:txBody>
-      </p:sp>
-      <p:sp>
-        <p:nvSpPr>
-          <p:cNvPr id="28" name="Text 21"/>
-          <p:cNvSpPr txBox="1"/>
-          <p:nvPr/>
-        </p:nvSpPr>
-        <p:spPr>
-          <a:xfrm>
-            <a:off x="822960" y="4828032"/>
-            <a:ext cx="6309360" cy="1051560"/>
-          </a:xfrm>
-          <a:prstGeom prst="rect">
-            <a:avLst/>
-          </a:prstGeom>
-          <a:noFill/>
-          <a:ln/>
-        </p:spPr>
-        <p:txBody>
-          <a:bodyPr wrap="square" lIns="0" tIns="0" rIns="0" bIns="0" rtlCol="0" anchor="t"/>
-          <a:lstStyle/>
-          <a:p>
-            <a:pPr marL="177800" indent="-177800">
-              <a:spcAft>
-                <a:spcPts val="500"/>
-              </a:spcAft>
-              <a:buSzPct val="100000"/>
-              <a:buChar char="•"/>
-            </a:pPr>
-            <a:r>
-              <a:rPr lang="en-US" sz="1300" dirty="0">
-                <a:solidFill>
-                  <a:schemeClr val="bg1"/>
-                </a:solidFill>
-              </a:rPr>
-              <a:t>Jede Kassenbehandlung braucht eine gültige Verordnung auf Muster 13.</a:t>
-            </a:r>
-            <a:endParaRPr lang="en-US" sz="1400" dirty="0"/>
-          </a:p>
-          <a:p>
-            <a:pPr marL="177800" indent="-177800">
-              <a:spcAft>
-                <a:spcPts val="500"/>
-              </a:spcAft>
-              <a:buSzPct val="100000"/>
-              <a:buChar char="•"/>
-            </a:pPr>
-            <a:r>
-              <a:rPr lang="en-US" sz="1300" dirty="0">
-                <a:solidFill>
-                  <a:schemeClr val="bg1"/>
-                </a:solidFill>
-              </a:rPr>
-              <a:t>Was gültig ist, regeln öffentliche Regelwerke von G-BA und KBV.</a:t>
-            </a:r>
-            <a:endParaRPr lang="en-US" sz="1400" dirty="0"/>
-          </a:p>
-          <a:p>
-            <a:pPr marL="177800" indent="-177800">
-              <a:spcAft>
-                <a:spcPts val="500"/>
-              </a:spcAft>
-              <a:buSzPct val="100000"/>
-              <a:buChar char="•"/>
-            </a:pPr>
-            <a:r>
-              <a:rPr lang="en-US" sz="1300" dirty="0">
-                <a:solidFill>
-                  <a:schemeClr val="bg1"/>
-                </a:solidFill>
-              </a:rPr>
-              <a:t>Fehler entdeckt? Dann kürzt die Kasse die Vergütung (Absetzung).</a:t>
-            </a:r>
-            <a:endParaRPr lang="en-US" sz="1400" dirty="0"/>
-          </a:p>
-        </p:txBody>
-      </p:sp>
-      <p:sp>
-        <p:nvSpPr>
-          <p:cNvPr id="29" name="Muster 13 (Blankoformular mit Feldnummern) Rahmen"/>
-          <p:cNvSpPr/>
-          <p:nvPr/>
-        </p:nvSpPr>
-        <p:spPr>
-          <a:xfrm>
-            <a:off x="8170795" y="1289304"/>
-            <a:ext cx="2888243" cy="4325112"/>
-          </a:xfrm>
-          <a:prstGeom prst="rect">
-            <a:avLst/>
-          </a:prstGeom>
-          <a:solidFill>
-            <a:srgbClr val="FFFFFF"/>
-          </a:solidFill>
-          <a:ln w="9525">
-            <a:solidFill>
-              <a:srgbClr val="C9D6D3"/>
-            </a:solidFill>
-            <a:prstDash val="solid"/>
-          </a:ln>
-          <a:effectLst>
-            <a:outerShdw sx="100000" sy="100000" kx="0" ky="0" algn="bl" rotWithShape="0" blurRad="50800" dist="25400" dir="5400000">
-              <a:srgbClr val="000000">
-                <a:alpha val="18000"/>
-              </a:srgbClr>
-            </a:outerShdw>
-          </a:effectLst>
-        </p:spPr>
-        <p:txBody>
-          <a:bodyPr/>
-          <a:p/>
-        </p:txBody>
-      </p:sp>
-      <p:pic>
-        <p:nvPicPr>
-          <p:cNvPr id="30" name="Muster 13 (Blankoformular mit Feldnummern)" descr="Muster 13 (Blankoformular mit Feldnummern)">    </p:cNvPr>
-          <p:cNvPicPr>
-            <a:picLocks noChangeAspect="1"/>
-          </p:cNvPicPr>
-          <p:nvPr/>
-        </p:nvPicPr>
-        <p:blipFill>
-          <a:blip r:embed="rId6"/>
-          <a:stretch>
-            <a:fillRect/>
-          </a:stretch>
-        </p:blipFill>
-        <p:spPr>
-          <a:xfrm>
-            <a:off x="8207371" y="1325880"/>
-            <a:ext cx="2815091" cy="4251960"/>
-          </a:xfrm>
-          <a:prstGeom prst="rect">
-            <a:avLst/>
-          </a:prstGeom>
-        </p:spPr>
-      </p:pic>
-      <p:sp>
-        <p:nvSpPr>
-          <p:cNvPr id="31" name="Text 23"/>
-          <p:cNvSpPr txBox="1"/>
-          <p:nvPr/>
-        </p:nvSpPr>
-        <p:spPr>
-          <a:xfrm>
-            <a:off x="7452360" y="5650992"/>
-            <a:ext cx="4325112" cy="292608"/>
-          </a:xfrm>
-          <a:prstGeom prst="rect">
-            <a:avLst/>
-          </a:prstGeom>
-          <a:noFill/>
-          <a:ln/>
-        </p:spPr>
-        <p:txBody>
-          <a:bodyPr wrap="square" lIns="0" tIns="0" rIns="0" bIns="0" rtlCol="0" anchor="t"/>
-          <a:lstStyle/>
-          <a:p>
-            <a:pPr algn="ctr" indent="0" marL="0">
-              <a:buNone/>
-            </a:pPr>
-            <a:r>
-              <a:rPr lang="en-US" sz="1100" i="1" dirty="0">
-                <a:solidFill>
-                  <a:schemeClr val="accent5"/>
-                </a:solidFill>
-              </a:rPr>
-              <a:t>Muster 13: Diese Felder prüft die Rezeption heute von Hand</a:t>
-            </a:r>
-            <a:endParaRPr lang="en-US" sz="1100" dirty="0"/>
-          </a:p>
-        </p:txBody>
-      </p:sp>
-      <p:sp>
-        <p:nvSpPr>
-          <p:cNvPr id="32" name="Text 24"/>
-          <p:cNvSpPr txBox="1"/>
-          <p:nvPr/>
-        </p:nvSpPr>
-        <p:spPr>
-          <a:xfrm>
-            <a:off x="548640" y="6035040"/>
-            <a:ext cx="11064240" cy="329184"/>
-          </a:xfrm>
-          <a:prstGeom prst="rect">
-            <a:avLst/>
-          </a:prstGeom>
-          <a:noFill/>
-          <a:ln/>
-        </p:spPr>
-        <p:txBody>
-          <a:bodyPr wrap="square" lIns="0" tIns="0" rIns="0" bIns="0" rtlCol="0" anchor="t"/>
-          <a:lstStyle/>
-          <a:p>
-            <a:pPr indent="0" marL="0">
-              <a:buNone/>
-            </a:pPr>
-            <a:r>
-              <a:rPr lang="en-US" sz="1000" i="1" dirty="0">
-                <a:solidFill>
-                  <a:schemeClr val="accent5"/>
-                </a:solidFill>
-              </a:rPr>
-              <a:t>Quellen: Field Study 16.10.2026 und Nachtrag 23.10.2026 · Bild: KV Sachsen-Anhalt, Ausfüllhilfe Muster 13, Stand 01.01.2021 (Blankoformular)</a:t>
-            </a:r>
-            <a:endParaRPr lang="en-US" sz="1000" dirty="0"/>
-          </a:p>
-        </p:txBody>
-      </p:sp>
-      <p:sp>
-        <p:nvSpPr>
-          <p:cNvPr id="25" name="Slide Number Placeholder 0"/>
-          <p:cNvSpPr>
-            <a:spLocks noGrp="1"/>
-          </p:cNvSpPr>
-          <p:nvPr>
-            <p:ph type="sldNum" sz="quarter" idx="4294967295"/>
-          </p:nvPr>
-        </p:nvSpPr>
-        <p:spPr>
-          <a:xfrm>
-            <a:off x="11201400" y="6419088"/>
-            <a:ext cx="457200" cy="274320"/>
-          </a:xfrm>
-          <a:prstGeom prst="rect">
-            <a:avLst/>
-          </a:prstGeom>
-          <a:extLst>
-            <a:ext uri="{C572A759-6A51-4108-AA02-DFA0A04FC94B}">
-              <ma14:wrappingTextBoxFlag xmlns:ma14="http://schemas.microsoft.com/office/mac/drawingml/2011/main" val="0"/>
-            </a:ext>
-          </a:extLst>
-        </p:spPr>
-        <p:txBody>
-          <a:bodyPr/>
-          <a:lstStyle>
-            <a:lvl1pPr>
-              <a:defRPr sz="1000">
-                <a:solidFill>
-                  <a:schemeClr val="accent5"/>
-                </a:solidFill>
-                <a:latin typeface="Calibri"/>
-                <a:ea typeface="Calibri"/>
-                <a:cs typeface="Calibri"/>
-              </a:defRPr>
-            </a:lvl1pPr>
-          </a:lstStyle>
-          <a:p>
-            <a:pPr algn="r"/>
-            <a:fld id="{F7021451-1387-4CA6-816F-3879F97B5CBC}" type="slidenum">
-              <a:rPr b="0" lang="en-US"/>
-              <a:t>3</a:t>
-            </a:fld>
-            <a:endParaRPr lang="en-US"/>
-          </a:p>
-        </p:txBody>
-      </p:sp>
-    </p:spTree>
-  </p:cSld>
-  <p:clrMapOvr>
-    <a:masterClrMapping/>
-  </p:clrMapOvr>
-</p:sld>
-</file>
-
-<file path=ppt/slides/slide30.xml><?xml version="1.0" encoding="utf-8"?>
+<file path=ppt/slides/slide31.xml><?xml version="1.0" encoding="utf-8"?>
 <p:sld xmlns:a="http://schemas.openxmlformats.org/drawingml/2006/main" xmlns:r="http://schemas.openxmlformats.org/officeDocument/2006/relationships" xmlns:p="http://schemas.openxmlformats.org/presentationml/2006/main">
   <p:cSld name="Slide 30">
     <p:spTree>
@@ -40259,7 +40776,7 @@
 </p:sld>
 </file>
 
-<file path=ppt/slides/slide31.xml><?xml version="1.0" encoding="utf-8"?>
+<file path=ppt/slides/slide32.xml><?xml version="1.0" encoding="utf-8"?>
 <p:sld xmlns:a="http://schemas.openxmlformats.org/drawingml/2006/main" xmlns:r="http://schemas.openxmlformats.org/officeDocument/2006/relationships" xmlns:p="http://schemas.openxmlformats.org/presentationml/2006/main">
   <p:cSld name="Slide 31">
     <p:spTree>
@@ -41019,7 +41536,7 @@
 </p:sld>
 </file>
 
-<file path=ppt/slides/slide32.xml><?xml version="1.0" encoding="utf-8"?>
+<file path=ppt/slides/slide33.xml><?xml version="1.0" encoding="utf-8"?>
 <p:sld xmlns:a="http://schemas.openxmlformats.org/drawingml/2006/main" xmlns:r="http://schemas.openxmlformats.org/officeDocument/2006/relationships" xmlns:p="http://schemas.openxmlformats.org/presentationml/2006/main">
   <p:cSld name="Slide 32">
     <p:spTree>
@@ -42934,523 +43451,6 @@
 </p:sld>
 </file>
 
-<file path=ppt/slides/slide33.xml><?xml version="1.0" encoding="utf-8"?>
-<p:sld xmlns:a="http://schemas.openxmlformats.org/drawingml/2006/main" xmlns:p="http://schemas.openxmlformats.org/presentationml/2006/main" xmlns:r="http://schemas.openxmlformats.org/officeDocument/2006/relationships">
-  <p:cSld>
-    <p:spTree>
-      <p:nvGrpSpPr>
-        <p:cNvPr id="2" name=""/>
-        <p:cNvGrpSpPr/>
-        <p:nvPr/>
-      </p:nvGrpSpPr>
-      <p:grpSpPr/>
-      <p:sp>
-        <p:nvSpPr>
-          <p:cNvPr id="3" name="Text 0"/>
-          <p:cNvSpPr/>
-          <p:nvPr>
-            <p:ph idx="100" type="title" hasCustomPrompt="1"/>
-          </p:nvPr>
-        </p:nvSpPr>
-        <p:spPr>
-          <a:xfrm>
-            <a:off x="548640" y="347472"/>
-            <a:ext cx="9326880" cy="685800"/>
-          </a:xfrm>
-          <a:prstGeom prst="rect">
-            <a:avLst/>
-          </a:prstGeom>
-          <a:noFill/>
-          <a:ln/>
-        </p:spPr>
-        <p:txBody>
-          <a:bodyPr wrap="square" lIns="0" tIns="0" rIns="0" bIns="0" rtlCol="0" anchor="ctr"/>
-          <a:lstStyle/>
-          <a:p>
-            <a:pPr algn="l" indent="0" marL="0">
-              <a:buNone/>
-            </a:pPr>
-            <a:r>
-              <a:rPr lang="en-US" sz="2800" b="1" dirty="0">
-                <a:solidFill>
-                  <a:schemeClr val="tx2"/>
-                </a:solidFill>
-                <a:latin typeface="Cambria" pitchFamily="34" charset="0"/>
-                <a:ea typeface="Cambria" pitchFamily="34" charset="-122"/>
-                <a:cs typeface="Cambria" pitchFamily="34" charset="-120"/>
-              </a:rPr>
-              <a:t>Der Workflow in n8n: vom Formular zur Ampel</a:t>
-            </a:r>
-            <a:endParaRPr lang="en-US" sz="2800" dirty="0"/>
-          </a:p>
-        </p:txBody>
-      </p:sp>
-      <p:sp>
-        <p:nvSpPr>
-          <p:cNvPr id="4" name="Rolleninhaber"/>
-          <p:cNvSpPr/>
-          <p:nvPr/>
-        </p:nvSpPr>
-        <p:spPr>
-          <a:xfrm>
-            <a:off x="10195560" y="457200"/>
-            <a:ext cx="1463040" cy="438912"/>
-          </a:xfrm>
-          <a:prstGeom prst="roundRect">
-            <a:avLst>
-              <a:gd name="adj" fmla="val 50000"/>
-            </a:avLst>
-          </a:prstGeom>
-          <a:solidFill>
-            <a:schemeClr val="accent3"/>
-          </a:solidFill>
-          <a:ln/>
-        </p:spPr>
-        <p:txBody>
-          <a:bodyPr/>
-          <a:p/>
-        </p:txBody>
-      </p:sp>
-      <p:pic>
-        <p:nvPicPr>
-          <p:cNvPr id="5" name="Personen-Symbol" descr="preencoded.png">    </p:cNvPr>
-          <p:cNvPicPr>
-            <a:picLocks noChangeAspect="1"/>
-          </p:cNvPicPr>
-          <p:nvPr/>
-        </p:nvPicPr>
-        <p:blipFill>
-          <a:blip r:embed="rId2"/>
-          <a:stretch>
-            <a:fillRect/>
-          </a:stretch>
-        </p:blipFill>
-        <p:spPr>
-          <a:xfrm>
-            <a:off x="10332720" y="548640"/>
-            <a:ext cx="256032" cy="256032"/>
-          </a:xfrm>
-          <a:prstGeom prst="rect">
-            <a:avLst/>
-          </a:prstGeom>
-        </p:spPr>
-      </p:pic>
-      <p:sp>
-        <p:nvSpPr>
-          <p:cNvPr id="6" name="Name Rolleninhaber"/>
-          <p:cNvSpPr txBox="1"/>
-          <p:nvPr/>
-        </p:nvSpPr>
-        <p:spPr>
-          <a:xfrm>
-            <a:off x="10625328" y="457200"/>
-            <a:ext cx="960120" cy="438912"/>
-          </a:xfrm>
-          <a:prstGeom prst="rect">
-            <a:avLst/>
-          </a:prstGeom>
-          <a:noFill/>
-          <a:ln/>
-        </p:spPr>
-        <p:txBody>
-          <a:bodyPr wrap="square" lIns="0" tIns="0" rIns="0" bIns="0" rtlCol="0" anchor="ctr"/>
-          <a:lstStyle/>
-          <a:p>
-            <a:pPr indent="0" marL="0">
-              <a:buNone/>
-            </a:pPr>
-            <a:r>
-              <a:rPr lang="en-US" sz="1500" b="1" dirty="0">
-                <a:solidFill>
-                  <a:schemeClr val="bg1"/>
-                </a:solidFill>
-              </a:rPr>
-              <a:t>Derk</a:t>
-            </a:r>
-            <a:endParaRPr lang="en-US" sz="1500" dirty="0"/>
-          </a:p>
-        </p:txBody>
-      </p:sp>
-      <p:sp>
-        <p:nvSpPr>
-          <p:cNvPr id="7" name="Slide Number Placeholder 0"/>
-          <p:cNvSpPr>
-            <a:spLocks noGrp="1"/>
-          </p:cNvSpPr>
-          <p:nvPr>
-            <p:ph type="sldNum" sz="quarter" idx="4294967295"/>
-          </p:nvPr>
-        </p:nvSpPr>
-        <p:spPr>
-          <a:xfrm>
-            <a:off x="11201400" y="6419088"/>
-            <a:ext cx="457200" cy="274320"/>
-          </a:xfrm>
-          <a:prstGeom prst="rect">
-            <a:avLst/>
-          </a:prstGeom>
-          <a:extLst>
-            <a:ext uri="{C572A759-6A51-4108-AA02-DFA0A04FC94B}">
-              <ma14:wrappingTextBoxFlag xmlns:ma14="http://schemas.microsoft.com/office/mac/drawingml/2011/main" val="0"/>
-            </a:ext>
-          </a:extLst>
-        </p:spPr>
-        <p:txBody>
-          <a:bodyPr/>
-          <a:lstStyle>
-            <a:lvl1pPr>
-              <a:defRPr sz="1000">
-                <a:solidFill>
-                  <a:schemeClr val="accent5"/>
-                </a:solidFill>
-                <a:latin typeface="Calibri"/>
-                <a:ea typeface="Calibri"/>
-                <a:cs typeface="Calibri"/>
-              </a:defRPr>
-            </a:lvl1pPr>
-          </a:lstStyle>
-          <a:p>
-            <a:pPr algn="r"/>
-            <a:fld id="{F7021451-1387-4CA6-816F-3879F97B5CBC}" type="slidenum">
-              <a:rPr b="0" lang="en-US"/>
-              <a:t>22</a:t>
-            </a:fld>
-            <a:endParaRPr lang="en-US"/>
-          </a:p>
-        </p:txBody>
-      </p:sp>
-      <p:sp>
-        <p:nvSpPr>
-          <p:cNvPr id="8" name="Einordnung"/>
-          <p:cNvSpPr/>
-          <p:nvPr/>
-        </p:nvSpPr>
-        <p:spPr>
-          <a:xfrm>
-            <a:off x="8625840" y="1325880"/>
-            <a:ext cx="3014472" cy="4526280"/>
-          </a:xfrm>
-          <a:prstGeom prst="roundRect">
-            <a:avLst>
-              <a:gd name="adj" fmla="val 2010"/>
-            </a:avLst>
-          </a:prstGeom>
-          <a:solidFill>
-            <a:schemeClr val="tx2"/>
-          </a:solidFill>
-          <a:ln/>
-        </p:spPr>
-        <p:txBody>
-          <a:bodyPr/>
-          <a:p/>
-        </p:txBody>
-      </p:sp>
-      <p:sp>
-        <p:nvSpPr>
-          <p:cNvPr id="9" name="Text 4"/>
-          <p:cNvSpPr txBox="1"/>
-          <p:nvPr/>
-        </p:nvSpPr>
-        <p:spPr>
-          <a:xfrm>
-            <a:off x="8854440" y="1463040"/>
-            <a:ext cx="2557272" cy="384048"/>
-          </a:xfrm>
-          <a:prstGeom prst="rect">
-            <a:avLst/>
-          </a:prstGeom>
-          <a:noFill/>
-          <a:ln/>
-        </p:spPr>
-        <p:txBody>
-          <a:bodyPr wrap="square" lIns="0" tIns="0" rIns="0" bIns="0" rtlCol="0" anchor="t"/>
-          <a:lstStyle/>
-          <a:p>
-            <a:pPr indent="0" marL="0">
-              <a:buNone/>
-            </a:pPr>
-            <a:r>
-              <a:rPr lang="en-US" sz="1800" b="1" dirty="0">
-                <a:solidFill>
-                  <a:schemeClr val="bg1"/>
-                </a:solidFill>
-                <a:latin typeface="Cambria" pitchFamily="34" charset="0"/>
-                <a:ea typeface="Cambria" pitchFamily="34" charset="-122"/>
-                <a:cs typeface="Cambria" pitchFamily="34" charset="-120"/>
-              </a:rPr>
-              <a:t>Was man sieht</a:t>
-            </a:r>
-            <a:endParaRPr lang="en-US" sz="1800" dirty="0"/>
-          </a:p>
-        </p:txBody>
-      </p:sp>
-      <p:sp>
-        <p:nvSpPr>
-          <p:cNvPr id="10" name="Text 5"/>
-          <p:cNvSpPr txBox="1"/>
-          <p:nvPr/>
-        </p:nvSpPr>
-        <p:spPr>
-          <a:xfrm>
-            <a:off x="8854440" y="1965960"/>
-            <a:ext cx="2557272" cy="3749040"/>
-          </a:xfrm>
-          <a:prstGeom prst="rect">
-            <a:avLst/>
-          </a:prstGeom>
-          <a:noFill/>
-          <a:ln/>
-        </p:spPr>
-        <p:txBody>
-          <a:bodyPr wrap="square" lIns="0" tIns="0" rIns="0" bIns="0" rtlCol="0" anchor="t"/>
-          <a:lstStyle/>
-          <a:p>
-            <a:pPr marL="177800" indent="-177800">
-              <a:spcAft>
-                <a:spcPts val="500"/>
-              </a:spcAft>
-              <a:buSzPct val="100000"/>
-              <a:buChar char="•"/>
-            </a:pPr>
-            <a:r>
-              <a:rPr lang="en-US" sz="1300" dirty="0">
-                <a:solidFill>
-                  <a:schemeClr val="bg1"/>
-                </a:solidFill>
-              </a:rPr>
-              <a:t>35 Knoten, ein Workflow für Formular und Chat</a:t>
-            </a:r>
-            <a:endParaRPr lang="en-US" sz="1400" dirty="0"/>
-          </a:p>
-          <a:p>
-            <a:pPr marL="177800" indent="-177800">
-              <a:spcAft>
-                <a:spcPts val="500"/>
-              </a:spcAft>
-              <a:buSzPct val="100000"/>
-              <a:buChar char="•"/>
-            </a:pPr>
-            <a:r>
-              <a:rPr lang="en-US" sz="1300" dirty="0">
-                <a:solidFill>
-                  <a:schemeClr val="bg1"/>
-                </a:solidFill>
-              </a:rPr>
-              <a:t>Code-Knoten rechnen Fristen, Höchstmenge, Leitsymptomatik und Frequenz</a:t>
-            </a:r>
-            <a:endParaRPr lang="en-US" sz="1400" dirty="0"/>
-          </a:p>
-          <a:p>
-            <a:pPr marL="177800" indent="-177800">
-              <a:spcAft>
-                <a:spcPts val="500"/>
-              </a:spcAft>
-              <a:buSzPct val="100000"/>
-              <a:buChar char="•"/>
-            </a:pPr>
-            <a:r>
-              <a:rPr lang="en-US" sz="1300" dirty="0">
-                <a:solidFill>
-                  <a:schemeClr val="bg1"/>
-                </a:solidFill>
-              </a:rPr>
-              <a:t>Vier Prüf-Agenten: Formal, Diagnose, Mengen, Fristen</a:t>
-            </a:r>
-            <a:endParaRPr lang="en-US" sz="1400" dirty="0"/>
-          </a:p>
-          <a:p>
-            <a:pPr marL="177800" indent="-177800">
-              <a:spcAft>
-                <a:spcPts val="500"/>
-              </a:spcAft>
-              <a:buSzPct val="100000"/>
-              <a:buChar char="•"/>
-            </a:pPr>
-            <a:r>
-              <a:rPr lang="en-US" sz="1300" dirty="0">
-                <a:solidFill>
-                  <a:schemeClr val="bg1"/>
-                </a:solidFill>
-              </a:rPr>
-              <a:t>Die Ampel bildet der Code aus den Befunden</a:t>
-            </a:r>
-            <a:endParaRPr lang="en-US" sz="1400" dirty="0"/>
-          </a:p>
-          <a:p>
-            <a:pPr marL="177800" indent="-177800">
-              <a:spcAft>
-                <a:spcPts val="500"/>
-              </a:spcAft>
-              <a:buSzPct val="100000"/>
-              <a:buChar char="•"/>
-            </a:pPr>
-            <a:r>
-              <a:rPr lang="en-US" sz="1300" dirty="0">
-                <a:solidFill>
-                  <a:schemeClr val="bg1"/>
-                </a:solidFill>
-              </a:rPr>
-              <a:t>Test-Läufe: Median 34 s je Prüfung</a:t>
-            </a:r>
-            <a:endParaRPr lang="en-US" sz="1400" dirty="0"/>
-          </a:p>
-          <a:p>
-            <a:pPr marL="0" indent="0">
-              <a:spcBef>
-                <a:spcPts val="1800"/>
-              </a:spcBef>
-              <a:spcAft>
-                <a:spcPts val="500"/>
-              </a:spcAft>
-              <a:buNone/>
-            </a:pPr>
-            <a:r>
-              <a:rPr lang="en-US" sz="1300" dirty="0" b="1">
-                <a:solidFill>
-                  <a:schemeClr val="bg1"/>
-                </a:solidFill>
-              </a:rPr>
-              <a:t>Merkpunkt: Was sich als Regel aufschreiben lässt, rechnet der Code.</a:t>
-            </a:r>
-            <a:endParaRPr lang="en-US" sz="1400" dirty="0"/>
-          </a:p>
-        </p:txBody>
-      </p:sp>
-      <p:sp>
-        <p:nvSpPr>
-          <p:cNvPr id="11" name="Text 6"/>
-          <p:cNvSpPr txBox="1"/>
-          <p:nvPr/>
-        </p:nvSpPr>
-        <p:spPr>
-          <a:xfrm>
-            <a:off x="548640" y="6035040"/>
-            <a:ext cx="11064240" cy="329184"/>
-          </a:xfrm>
-          <a:prstGeom prst="rect">
-            <a:avLst/>
-          </a:prstGeom>
-          <a:noFill/>
-          <a:ln/>
-        </p:spPr>
-        <p:txBody>
-          <a:bodyPr wrap="square" lIns="0" tIns="0" rIns="0" bIns="0" rtlCol="0" anchor="t"/>
-          <a:lstStyle/>
-          <a:p>
-            <a:pPr indent="0" marL="0">
-              <a:buNone/>
-            </a:pPr>
-            <a:r>
-              <a:rPr lang="en-US" sz="1000" i="1" dirty="0">
-                <a:solidFill>
-                  <a:schemeClr val="accent5"/>
-                </a:solidFill>
-              </a:rPr>
-              <a:t>Screenshot aus der n8n Cloud, Workflow „Verordnungcheck_gemerged“ · Stand 28.10.2026</a:t>
-            </a:r>
-            <a:endParaRPr lang="en-US" sz="1000" dirty="0"/>
-          </a:p>
-        </p:txBody>
-      </p:sp>
-      <p:sp>
-        <p:nvSpPr>
-          <p:cNvPr id="12" name="Werkzeug"/>
-          <p:cNvSpPr/>
-          <p:nvPr/>
-        </p:nvSpPr>
-        <p:spPr>
-          <a:xfrm>
-            <a:off x="548640" y="5336505"/>
-            <a:ext cx="7905750" cy="515655"/>
-          </a:xfrm>
-          <a:prstGeom prst="roundRect">
-            <a:avLst>
-              <a:gd name="adj" fmla="val 3200"/>
-            </a:avLst>
-          </a:prstGeom>
-          <a:solidFill>
-            <a:schemeClr val="bg2"/>
-          </a:solidFill>
-          <a:ln/>
-        </p:spPr>
-        <p:txBody>
-          <a:bodyPr/>
-          <a:p/>
-        </p:txBody>
-      </p:sp>
-      <p:sp>
-        <p:nvSpPr>
-          <p:cNvPr id="13" name="Text 20"/>
-          <p:cNvSpPr txBox="1"/>
-          <p:nvPr/>
-        </p:nvSpPr>
-        <p:spPr>
-          <a:xfrm>
-            <a:off x="731520" y="5409657"/>
-            <a:ext cx="7539990" cy="369351"/>
-          </a:xfrm>
-          <a:prstGeom prst="rect">
-            <a:avLst/>
-          </a:prstGeom>
-          <a:noFill/>
-          <a:ln/>
-        </p:spPr>
-        <p:txBody>
-          <a:bodyPr wrap="square" lIns="0" tIns="0" rIns="0" bIns="0" rtlCol="0" anchor="t"/>
-          <a:lstStyle/>
-          <a:p>
-            <a:pPr indent="0" marL="0">
-              <a:buNone/>
-            </a:pPr>
-            <a:r>
-              <a:rPr lang="en-US" sz="1300" dirty="0">
-                <a:solidFill>
-                  <a:schemeClr val="tx1"/>
-                </a:solidFill>
-              </a:rPr>
-              <a:t>Lesen von links nach rechts: Eingang (Formular oder Chat) → Fakten im Code → vier Prüfer → Ampel → Protokoll in Supabase → Antwort an das Formular.</a:t>
-            </a:r>
-            <a:endParaRPr lang="en-US" sz="1400" dirty="0"/>
-          </a:p>
-        </p:txBody>
-      </p:sp>
-      <p:pic>
-        <p:nvPicPr>
-          <p:cNvPr id="14" name="Screenshot n8n Workflow" descr="n8n-workflow.png"/>
-          <p:cNvPicPr>
-            <a:picLocks noChangeAspect="1"/>
-          </p:cNvPicPr>
-          <p:nvPr/>
-        </p:nvPicPr>
-        <p:blipFill>
-          <a:blip r:embed="rId3"/>
-          <a:stretch>
-            <a:fillRect/>
-          </a:stretch>
-        </p:blipFill>
-        <p:spPr>
-          <a:xfrm>
-            <a:off x="548640" y="1325880"/>
-            <a:ext cx="7905750" cy="3919185"/>
-          </a:xfrm>
-          <a:prstGeom prst="rect">
-            <a:avLst/>
-          </a:prstGeom>
-          <a:ln w="9525">
-            <a:solidFill>
-              <a:srgbClr val="C9D3D0"/>
-            </a:solidFill>
-          </a:ln>
-        </p:spPr>
-      </p:pic>
-    </p:spTree>
-  </p:cSld>
-  <p:clrMapOvr>
-    <a:masterClrMapping/>
-  </p:clrMapOvr>
-</p:sld>
-</file>
-
 <file path=ppt/slides/slide4.xml><?xml version="1.0" encoding="utf-8"?>
 <p:sld xmlns:a="http://schemas.openxmlformats.org/drawingml/2006/main" xmlns:r="http://schemas.openxmlformats.org/officeDocument/2006/relationships" xmlns:p="http://schemas.openxmlformats.org/presentationml/2006/main">
   <p:cSld name="Slide 4">
@@ -45062,7 +45062,7 @@
                   <a:schemeClr val="accent1"/>
                 </a:solidFill>
               </a:rPr>
-              <a:t>3–6 % vom Umsatz</a:t>
+              <a:t>1,9 % vom Umsatz</a:t>
             </a:r>
             <a:endParaRPr lang="en-US" sz="1300" dirty="0"/>
           </a:p>

</xml_diff>

<commit_message>
Architekturhinweis PII-Reduktion (Chat: NER-Modell plus Regeln, Formular: Regeln) in Präsentation, Kapitel 4 und Doku
Co-Authored-By: Claude Sonnet 5.5 <noreply@anthropic.com>
Claude-Session: https://claude.ai/code/session_01Fiy9oFcgEmSsPPtPA47rVp
</commit_message>
<xml_diff>
--- a/docs/praesentation/Verordnungs-Check_IHK_3x15min_2026-10-27.pptx
+++ b/docs/praesentation/Verordnungs-Check_IHK_3x15min_2026-10-27.pptx
@@ -1664,12 +1664,23 @@
           <a:lstStyle/>
           <a:p>
             <a:r>
-              <a:rPr lang="en-US" dirty="0"/>
-              <a:t>VALENTIN · ca. 1,25 min (IHK: Tool-Auswahl und Einsatzplanung).
-Der Ablauf in fünf Schritten. Die dunklen Kästen sind Code: Fakten berechnen und Ampel bilden. Die hellen nutzen das Sprachmodell.
-Der Leitsatz ist kein Dogma, sondern Ergebnis unserer Tests – das zeige ich auf der nächsten Folie.</a:t>
+              <a:t>VALENTIN · ca. 1,25 min (IHK: Tool-Auswahl und Einsatzplanung).</a:t>
             </a:r>
-            <a:endParaRPr lang="en-US" dirty="0"/>
+          </a:p>
+          <a:p>
+            <a:r>
+              <a:t>Der Ablauf in fünf Schritten. Die dunklen Kästen sind Code: Fakten berechnen und Ampel bilden. Die hellen nutzen das Sprachmodell.</a:t>
+            </a:r>
+          </a:p>
+          <a:p>
+            <a:r>
+              <a:t>Der Leitsatz ist kein Dogma, sondern Ergebnis unserer Tests – das zeige ich auf der nächsten Folie.</a:t>
+            </a:r>
+          </a:p>
+          <a:p>
+            <a:r>
+              <a:t>PII-Reduktion (Architekturhinweis): Läuft die Eingabe über den Chat, geht der Text zuerst durch das NER-Modell bert-base-multilingual-cased-ner-hrl plus Regeln. Bei der Formular-Eingabe geht es regelbasiert weiter, Feld für Feld. Im Cloud-Prototyp greifen im Chat heute nur die Regeln, das Modell läuft lokal – echte Daten gehören deshalb nur in das Formular.</a:t>
+            </a:r>
           </a:p>
         </p:txBody>
       </p:sp>
@@ -1846,13 +1857,28 @@
           <a:lstStyle/>
           <a:p>
             <a:r>
-              <a:rPr lang="en-US" dirty="0"/>
-              <a:t>VALENTIN · ca. 1,25 min (IHK: Tool-Auswahl und Einsatzplanung).
-Die übrigen Entscheidungen jeweils mit Alternative.
-Hervorheben: Patientendaten ersetzen wir, bevor das Modell sie sieht – das ist auch der Übergang zur Governance.
-Und: Der Mensch entscheidet. Das ist nicht nur fachlich richtig, sondern auch für die rechtliche Einordnung wichtig.</a:t>
+              <a:t>VALENTIN · ca. 1,25 min (IHK: Tool-Auswahl und Einsatzplanung).</a:t>
             </a:r>
-            <a:endParaRPr lang="en-US" dirty="0"/>
+          </a:p>
+          <a:p>
+            <a:r>
+              <a:t>Die übrigen Entscheidungen jeweils mit Alternative.</a:t>
+            </a:r>
+          </a:p>
+          <a:p>
+            <a:r>
+              <a:t>Hervorheben: Patientendaten ersetzen wir, bevor das Modell sie sieht – das ist auch der Übergang zur Governance.</a:t>
+            </a:r>
+          </a:p>
+          <a:p>
+            <a:r>
+              <a:t>Und: Der Mensch entscheidet. Das ist nicht nur fachlich richtig, sondern auch für die rechtliche Einordnung wichtig.</a:t>
+            </a:r>
+          </a:p>
+          <a:p>
+            <a:r>
+              <a:t>Zur PII-Reduktion: Chat über NER-Modell (bert-base-multilingual-cased-ner-hrl) plus Regeln, Formular rein regelbasiert (Folie 16).</a:t>
+            </a:r>
           </a:p>
         </p:txBody>
       </p:sp>
@@ -2215,16 +2241,43 @@
           <a:lstStyle/>
           <a:p>
             <a:r>
-              <a:rPr lang="en-US" dirty="0"/>
-              <a:t>VALENTIN · ca. 1,5 min (IHK: rechtliche Rahmenbedingungen).
-Verordnungen sind Gesundheitsdaten nach Art. 9 DSGVO.
-Im Prototyp verarbeiten wir nur synthetische Daten – damit fallen keine personenbezogenen Daten an.
-Für den Echtbetrieb ist die Rechtsgrundlage Art. 9 Abs. 2 lit. h mit § 22 BDSG – die gleiche Grundlage, auf der die Praxis heute schon Verordnungen verarbeitet.
-Zusätzlich zum Datenschutz gilt das Berufsgeheimnis nach § 203 StGB: Unsere Dienstleister sind mitwirkende Personen und müssen zur Verschwiegenheit verpflichtet werden.
-Offen vor Echtbetrieb: Datenschutz-Folgenabschätzung, OpenAI mit EU-Datenresidenz oder Data Privacy Framework.
-Übergabe an Derk: Wie gut funktioniert das heute?</a:t>
+              <a:t>VALENTIN · ca. 1,5 min (IHK: rechtliche Rahmenbedingungen).</a:t>
             </a:r>
-            <a:endParaRPr lang="en-US" dirty="0"/>
+          </a:p>
+          <a:p>
+            <a:r>
+              <a:t>Verordnungen sind Gesundheitsdaten nach Art. 9 DSGVO.</a:t>
+            </a:r>
+          </a:p>
+          <a:p>
+            <a:r>
+              <a:t>Im Prototyp verarbeiten wir nur synthetische Daten – damit fallen keine personenbezogenen Daten an.</a:t>
+            </a:r>
+          </a:p>
+          <a:p>
+            <a:r>
+              <a:t>Für den Echtbetrieb ist die Rechtsgrundlage Art. 9 Abs. 2 lit. h mit § 22 BDSG – die gleiche Grundlage, auf der die Praxis heute schon Verordnungen verarbeitet.</a:t>
+            </a:r>
+          </a:p>
+          <a:p>
+            <a:r>
+              <a:t>Zusätzlich zum Datenschutz gilt das Berufsgeheimnis nach § 203 StGB: Unsere Dienstleister sind mitwirkende Personen und müssen zur Verschwiegenheit verpflichtet werden.</a:t>
+            </a:r>
+          </a:p>
+          <a:p>
+            <a:r>
+              <a:t>Offen vor Echtbetrieb: Datenschutz-Folgenabschätzung, OpenAI mit EU-Datenresidenz oder Data Privacy Framework.</a:t>
+            </a:r>
+          </a:p>
+          <a:p>
+            <a:r>
+              <a:t>Übergabe an Derk: Wie gut funktioniert das heute?</a:t>
+            </a:r>
+          </a:p>
+          <a:p>
+            <a:r>
+              <a:t>Datenminimierung technisch: Im Chat erkennt das NER-Modell Namen auch ohne Rollenwort, ergänzt um Regeln; im Formular ersetzen Regeln die Felder deterministisch. In der Cloud läuft im Chat bisher nur der Regelteil (Folie 16).</a:t>
+            </a:r>
           </a:p>
         </p:txBody>
       </p:sp>
@@ -6085,7 +6138,7 @@
       </p:sp>
       <p:graphicFrame>
         <p:nvGraphicFramePr>
-          <p:cNvPr id="11" name="Table 0"/>
+          <p:cNvPr id="35" name="Table 0"/>
           <p:cNvGraphicFramePr>
             <a:graphicFrameLocks noGrp="1"/>
           </p:cNvGraphicFramePr>
@@ -6943,7 +6996,7 @@
       </p:graphicFrame>
       <p:sp>
         <p:nvSpPr>
-          <p:cNvPr id="25" name="Slide Number Placeholder 0"/>
+          <p:cNvPr id="36" name="Slide Number Placeholder 0"/>
           <p:cNvSpPr>
             <a:spLocks noGrp="1"/>
           </p:cNvSpPr>
@@ -13304,7 +13357,7 @@
       </p:sp>
       <p:sp>
         <p:nvSpPr>
-          <p:cNvPr id="25" name="Slide Number Placeholder 0"/>
+          <p:cNvPr id="28" name="Slide Number Placeholder 0"/>
           <p:cNvSpPr>
             <a:spLocks noGrp="1"/>
           </p:cNvSpPr>
@@ -15022,7 +15075,7 @@
       </p:sp>
       <p:sp>
         <p:nvSpPr>
-          <p:cNvPr id="16" name="Text 12"/>
+          <p:cNvPr id="26" name="Text 12"/>
           <p:cNvSpPr txBox="1"/>
           <p:nvPr/>
         </p:nvSpPr>
@@ -15265,7 +15318,7 @@
         <p:spPr>
           <a:xfrm>
             <a:off x="548640" y="1325880"/>
-            <a:ext cx="2011680" cy="2057400"/>
+            <a:ext cx="2011680" cy="1720000"/>
           </a:xfrm>
           <a:prstGeom prst="roundRect">
             <a:avLst>
@@ -15374,8 +15427,8 @@
         </p:nvSpPr>
         <p:spPr>
           <a:xfrm>
-            <a:off x="731520" y="2148840"/>
-            <a:ext cx="1691640" cy="1143000"/>
+            <a:off x="731520" y="2100000"/>
+            <a:ext cx="1691640" cy="900000"/>
           </a:xfrm>
           <a:prstGeom prst="rect">
             <a:avLst/>
@@ -15410,7 +15463,7 @@
         </p:nvSpPr>
         <p:spPr>
           <a:xfrm rot="5400000">
-            <a:off x="2569464" y="2240280"/>
+            <a:off x="2569464" y="2112000"/>
             <a:ext cx="237744" cy="146304"/>
           </a:xfrm>
           <a:prstGeom prst="triangle">
@@ -15435,7 +15488,7 @@
         <p:spPr>
           <a:xfrm>
             <a:off x="2811780" y="1325880"/>
-            <a:ext cx="2011680" cy="2057400"/>
+            <a:ext cx="2011680" cy="1720000"/>
           </a:xfrm>
           <a:prstGeom prst="roundRect">
             <a:avLst>
@@ -15544,8 +15597,8 @@
         </p:nvSpPr>
         <p:spPr>
           <a:xfrm>
-            <a:off x="2994660" y="2148840"/>
-            <a:ext cx="1691640" cy="1143000"/>
+            <a:off x="2994660" y="2100000"/>
+            <a:ext cx="1691640" cy="900000"/>
           </a:xfrm>
           <a:prstGeom prst="rect">
             <a:avLst/>
@@ -15566,7 +15619,7 @@
                   <a:schemeClr val="tx1"/>
                 </a:solidFill>
               </a:rPr>
-              <a:t>Schema, Patientendaten entfernen</a:t>
+              <a:t>Patientendaten ersetzen, Angaben ins Schema (Hinweis unten)</a:t>
             </a:r>
             <a:endParaRPr lang="en-US" sz="1300" dirty="0"/>
           </a:p>
@@ -15580,7 +15633,7 @@
         </p:nvSpPr>
         <p:spPr>
           <a:xfrm rot="5400000">
-            <a:off x="4832604" y="2240280"/>
+            <a:off x="4832604" y="2112000"/>
             <a:ext cx="237744" cy="146304"/>
           </a:xfrm>
           <a:prstGeom prst="triangle">
@@ -15605,7 +15658,7 @@
         <p:spPr>
           <a:xfrm>
             <a:off x="5074920" y="1325880"/>
-            <a:ext cx="2011680" cy="2057400"/>
+            <a:ext cx="2011680" cy="1720000"/>
           </a:xfrm>
           <a:prstGeom prst="roundRect">
             <a:avLst>
@@ -15714,8 +15767,8 @@
         </p:nvSpPr>
         <p:spPr>
           <a:xfrm>
-            <a:off x="5257800" y="2148840"/>
-            <a:ext cx="1691640" cy="1143000"/>
+            <a:off x="5257800" y="2100000"/>
+            <a:ext cx="1691640" cy="900000"/>
           </a:xfrm>
           <a:prstGeom prst="rect">
             <a:avLst/>
@@ -15750,7 +15803,7 @@
         </p:nvSpPr>
         <p:spPr>
           <a:xfrm rot="5400000">
-            <a:off x="7095744" y="2240280"/>
+            <a:off x="7095744" y="2112000"/>
             <a:ext cx="237744" cy="146304"/>
           </a:xfrm>
           <a:prstGeom prst="triangle">
@@ -15775,7 +15828,7 @@
         <p:spPr>
           <a:xfrm>
             <a:off x="7338060" y="1325880"/>
-            <a:ext cx="2011680" cy="2057400"/>
+            <a:ext cx="2011680" cy="1720000"/>
           </a:xfrm>
           <a:prstGeom prst="roundRect">
             <a:avLst>
@@ -15884,8 +15937,8 @@
         </p:nvSpPr>
         <p:spPr>
           <a:xfrm>
-            <a:off x="7520940" y="2148840"/>
-            <a:ext cx="1691640" cy="1143000"/>
+            <a:off x="7520940" y="2100000"/>
+            <a:ext cx="1691640" cy="900000"/>
           </a:xfrm>
           <a:prstGeom prst="rect">
             <a:avLst/>
@@ -15920,7 +15973,7 @@
         </p:nvSpPr>
         <p:spPr>
           <a:xfrm rot="5400000">
-            <a:off x="9358884" y="2240280"/>
+            <a:off x="9358884" y="2112000"/>
             <a:ext cx="237744" cy="146304"/>
           </a:xfrm>
           <a:prstGeom prst="triangle">
@@ -15945,7 +15998,7 @@
         <p:spPr>
           <a:xfrm>
             <a:off x="9601200" y="1325880"/>
-            <a:ext cx="2011680" cy="2057400"/>
+            <a:ext cx="2011680" cy="1720000"/>
           </a:xfrm>
           <a:prstGeom prst="roundRect">
             <a:avLst>
@@ -16054,8 +16107,8 @@
         </p:nvSpPr>
         <p:spPr>
           <a:xfrm>
-            <a:off x="9784080" y="2148840"/>
-            <a:ext cx="1691640" cy="1143000"/>
+            <a:off x="9784080" y="2100000"/>
+            <a:ext cx="1691640" cy="900000"/>
           </a:xfrm>
           <a:prstGeom prst="rect">
             <a:avLst/>
@@ -16090,7 +16143,7 @@
         </p:nvSpPr>
         <p:spPr>
           <a:xfrm>
-            <a:off x="548640" y="3456432"/>
+            <a:off x="548640" y="3095000"/>
             <a:ext cx="7315200" cy="274320"/>
           </a:xfrm>
           <a:prstGeom prst="rect">
@@ -16126,8 +16179,8 @@
         </p:nvSpPr>
         <p:spPr>
           <a:xfrm>
-            <a:off x="548640" y="3840480"/>
-            <a:ext cx="5394960" cy="2057400"/>
+            <a:off x="548640" y="4590000"/>
+            <a:ext cx="5394960" cy="1610000"/>
           </a:xfrm>
           <a:prstGeom prst="roundRect">
             <a:avLst>
@@ -16152,7 +16205,7 @@
         </p:nvSpPr>
         <p:spPr>
           <a:xfrm>
-            <a:off x="777240" y="3977640"/>
+            <a:off x="777240" y="4727160"/>
             <a:ext cx="502920" cy="502920"/>
           </a:xfrm>
           <a:prstGeom prst="ellipse">
@@ -16184,7 +16237,7 @@
         </p:blipFill>
         <p:spPr>
           <a:xfrm>
-            <a:off x="902970" y="4103370"/>
+            <a:off x="902970" y="4852890"/>
             <a:ext cx="251460" cy="251460"/>
           </a:xfrm>
           <a:prstGeom prst="rect">
@@ -16200,7 +16253,7 @@
         </p:nvSpPr>
         <p:spPr>
           <a:xfrm>
-            <a:off x="1417320" y="3977640"/>
+            <a:off x="1417320" y="4727160"/>
             <a:ext cx="2743200" cy="502920"/>
           </a:xfrm>
           <a:prstGeom prst="rect">
@@ -16236,8 +16289,8 @@
         </p:nvSpPr>
         <p:spPr>
           <a:xfrm>
-            <a:off x="777240" y="4572000"/>
-            <a:ext cx="4937760" cy="1280160"/>
+            <a:off x="777240" y="5260000"/>
+            <a:ext cx="4937760" cy="900000"/>
           </a:xfrm>
           <a:prstGeom prst="rect">
             <a:avLst/>
@@ -16251,13 +16304,13 @@
           <a:p>
             <a:pPr marL="177800" indent="-177800">
               <a:spcAft>
-                <a:spcPts val="500"/>
+                <a:spcPts val="300"/>
               </a:spcAft>
               <a:buSzPct val="100000"/>
               <a:buChar char="•"/>
             </a:pPr>
             <a:r>
-              <a:rPr lang="en-US" sz="1300" dirty="0">
+              <a:rPr lang="en-US" sz="1200" dirty="0">
                 <a:solidFill>
                   <a:schemeClr val="tx1"/>
                 </a:solidFill>
@@ -16269,13 +16322,13 @@
           <a:p>
             <a:pPr marL="177800" indent="-177800">
               <a:spcAft>
-                <a:spcPts val="500"/>
+                <a:spcPts val="300"/>
               </a:spcAft>
               <a:buSzPct val="100000"/>
               <a:buChar char="•"/>
             </a:pPr>
             <a:r>
-              <a:rPr lang="en-US" sz="1300" dirty="0">
+              <a:rPr lang="en-US" sz="1200" dirty="0">
                 <a:solidFill>
                   <a:schemeClr val="tx1"/>
                 </a:solidFill>
@@ -16287,13 +16340,13 @@
           <a:p>
             <a:pPr marL="177800" indent="-177800">
               <a:spcAft>
-                <a:spcPts val="500"/>
+                <a:spcPts val="300"/>
               </a:spcAft>
               <a:buSzPct val="100000"/>
               <a:buChar char="•"/>
             </a:pPr>
             <a:r>
-              <a:rPr lang="en-US" sz="1300" dirty="0">
+              <a:rPr lang="en-US" sz="1200" dirty="0">
                 <a:solidFill>
                   <a:schemeClr val="tx1"/>
                 </a:solidFill>
@@ -16305,13 +16358,13 @@
           <a:p>
             <a:pPr marL="177800" indent="-177800">
               <a:spcAft>
-                <a:spcPts val="500"/>
+                <a:spcPts val="300"/>
               </a:spcAft>
               <a:buSzPct val="100000"/>
               <a:buChar char="•"/>
             </a:pPr>
             <a:r>
-              <a:rPr lang="en-US" sz="1300" dirty="0">
+              <a:rPr lang="en-US" sz="1200" dirty="0">
                 <a:solidFill>
                   <a:schemeClr val="tx1"/>
                 </a:solidFill>
@@ -16330,8 +16383,8 @@
         </p:nvSpPr>
         <p:spPr>
           <a:xfrm>
-            <a:off x="6126480" y="3840480"/>
-            <a:ext cx="5513832" cy="2057400"/>
+            <a:off x="6126480" y="4590000"/>
+            <a:ext cx="5513832" cy="1610000"/>
           </a:xfrm>
           <a:prstGeom prst="roundRect">
             <a:avLst>
@@ -16356,7 +16409,7 @@
         </p:nvSpPr>
         <p:spPr>
           <a:xfrm>
-            <a:off x="6355080" y="3977640"/>
+            <a:off x="6355080" y="4727160"/>
             <a:ext cx="502920" cy="502920"/>
           </a:xfrm>
           <a:prstGeom prst="ellipse">
@@ -16388,7 +16441,7 @@
         </p:blipFill>
         <p:spPr>
           <a:xfrm>
-            <a:off x="6480810" y="4103370"/>
+            <a:off x="6480810" y="4852890"/>
             <a:ext cx="251460" cy="251460"/>
           </a:xfrm>
           <a:prstGeom prst="rect">
@@ -16404,7 +16457,7 @@
         </p:nvSpPr>
         <p:spPr>
           <a:xfrm>
-            <a:off x="6995160" y="3977640"/>
+            <a:off x="6995160" y="4727160"/>
             <a:ext cx="4389120" cy="502920"/>
           </a:xfrm>
           <a:prstGeom prst="rect">
@@ -16440,8 +16493,8 @@
         </p:nvSpPr>
         <p:spPr>
           <a:xfrm>
-            <a:off x="6355080" y="4572000"/>
-            <a:ext cx="5074920" cy="1234440"/>
+            <a:off x="6355080" y="5260000"/>
+            <a:ext cx="5074920" cy="900000"/>
           </a:xfrm>
           <a:prstGeom prst="rect">
             <a:avLst/>
@@ -16470,7 +16523,7 @@
       </p:sp>
       <p:sp>
         <p:nvSpPr>
-          <p:cNvPr id="25" name="Slide Number Placeholder 0"/>
+          <p:cNvPr id="53" name="Slide Number Placeholder 0"/>
           <p:cNvSpPr>
             <a:spLocks noGrp="1"/>
           </p:cNvSpPr>
@@ -16513,6 +16566,272 @@
               <a:t>16</a:t>
             </a:fld>
             <a:endParaRPr lang="en-US"/>
+          </a:p>
+        </p:txBody>
+      </p:sp>
+      <p:sp>
+        <p:nvSpPr>
+          <p:cNvPr id="46" name="Hinweis PII-Reduktion"/>
+          <p:cNvSpPr/>
+          <p:nvPr/>
+        </p:nvSpPr>
+        <p:spPr>
+          <a:xfrm>
+            <a:off x="548640" y="3420000"/>
+            <a:ext cx="11064240" cy="1060000"/>
+          </a:xfrm>
+          <a:prstGeom prst="roundRect">
+            <a:avLst>
+              <a:gd name="adj" fmla="val 3556"/>
+            </a:avLst>
+          </a:prstGeom>
+          <a:solidFill>
+            <a:schemeClr val="bg1"/>
+          </a:solidFill>
+          <a:ln w="19050">
+            <a:solidFill>
+              <a:schemeClr val="accent1"/>
+            </a:solidFill>
+          </a:ln>
+        </p:spPr>
+        <p:txBody>
+          <a:bodyPr/>
+          <a:p/>
+        </p:txBody>
+      </p:sp>
+      <p:sp>
+        <p:nvSpPr>
+          <p:cNvPr id="47" name="Trenner"/>
+          <p:cNvSpPr/>
+          <p:nvPr/>
+        </p:nvSpPr>
+        <p:spPr>
+          <a:xfrm>
+            <a:off x="2700000" y="3550000"/>
+            <a:ext cx="12700" cy="800000"/>
+          </a:xfrm>
+          <a:prstGeom prst="rect">
+            <a:avLst/>
+          </a:prstGeom>
+          <a:solidFill>
+            <a:schemeClr val="accent1"/>
+          </a:solidFill>
+          <a:ln/>
+        </p:spPr>
+        <p:txBody>
+          <a:bodyPr/>
+          <a:p/>
+        </p:txBody>
+      </p:sp>
+      <p:sp>
+        <p:nvSpPr>
+          <p:cNvPr id="48" name="Trenner"/>
+          <p:cNvSpPr/>
+          <p:nvPr/>
+        </p:nvSpPr>
+        <p:spPr>
+          <a:xfrm>
+            <a:off x="7000000" y="3550000"/>
+            <a:ext cx="12700" cy="560000"/>
+          </a:xfrm>
+          <a:prstGeom prst="rect">
+            <a:avLst/>
+          </a:prstGeom>
+          <a:solidFill>
+            <a:schemeClr val="accent1"/>
+          </a:solidFill>
+          <a:ln/>
+        </p:spPr>
+        <p:txBody>
+          <a:bodyPr/>
+          <a:p/>
+        </p:txBody>
+      </p:sp>
+      <p:sp>
+        <p:nvSpPr>
+          <p:cNvPr id="49" name="Hinweis Label"/>
+          <p:cNvSpPr txBox="1"/>
+          <p:nvPr/>
+        </p:nvSpPr>
+        <p:spPr>
+          <a:xfrm>
+            <a:off x="731520" y="3520000"/>
+            <a:ext cx="1850000" cy="860000"/>
+          </a:xfrm>
+          <a:prstGeom prst="rect">
+            <a:avLst/>
+          </a:prstGeom>
+          <a:noFill/>
+          <a:ln/>
+        </p:spPr>
+        <p:txBody>
+          <a:bodyPr wrap="square" lIns="0" tIns="0" rIns="0" bIns="0" rtlCol="0" anchor="ctr"/>
+          <a:lstStyle/>
+          <a:p>
+            <a:pPr indent="0" marL="0">
+              <a:spcAft>
+                <a:spcPts val="3"/>
+              </a:spcAft>
+              <a:buNone/>
+            </a:pPr>
+            <a:r>
+              <a:rPr lang="de-DE" sz="1500" dirty="0" b="1">
+                <a:solidFill>
+                  <a:schemeClr val="tx2"/>
+                </a:solidFill>
+              </a:rPr>
+              <a:t>PII-Reduktion</a:t>
+            </a:r>
+          </a:p>
+          <a:p>
+            <a:pPr indent="0" marL="0">
+              <a:buNone/>
+            </a:pPr>
+            <a:r>
+              <a:rPr lang="de-DE" sz="1100" dirty="0" i="1">
+                <a:solidFill>
+                  <a:schemeClr val="accent5"/>
+                </a:solidFill>
+              </a:rPr>
+              <a:t>bevor ein Sprachmodell die Daten sieht</a:t>
+            </a:r>
+          </a:p>
+        </p:txBody>
+      </p:sp>
+      <p:sp>
+        <p:nvSpPr>
+          <p:cNvPr id="50" name="Hinweis Chat"/>
+          <p:cNvSpPr txBox="1"/>
+          <p:nvPr/>
+        </p:nvSpPr>
+        <p:spPr>
+          <a:xfrm>
+            <a:off x="2880000" y="3530000"/>
+            <a:ext cx="3980000" cy="640000"/>
+          </a:xfrm>
+          <a:prstGeom prst="rect">
+            <a:avLst/>
+          </a:prstGeom>
+          <a:noFill/>
+          <a:ln/>
+        </p:spPr>
+        <p:txBody>
+          <a:bodyPr wrap="square" lIns="0" tIns="0" rIns="0" bIns="0" rtlCol="0" anchor="t"/>
+          <a:lstStyle/>
+          <a:p>
+            <a:pPr indent="0" marL="0">
+              <a:spcAft>
+                <a:spcPts val="2"/>
+              </a:spcAft>
+              <a:buNone/>
+            </a:pPr>
+            <a:r>
+              <a:rPr lang="de-DE" sz="1300" dirty="0" b="1">
+                <a:solidFill>
+                  <a:schemeClr val="tx2"/>
+                </a:solidFill>
+              </a:rPr>
+              <a:t>Chat (Freitext)</a:t>
+            </a:r>
+          </a:p>
+          <a:p>
+            <a:pPr indent="0" marL="0">
+              <a:buNone/>
+            </a:pPr>
+            <a:r>
+              <a:rPr lang="de-DE" sz="1200" dirty="0">
+                <a:solidFill>
+                  <a:schemeClr val="tx1"/>
+                </a:solidFill>
+              </a:rPr>
+              <a:t>NER-Modell bert-base-multilingual-cased-ner-hrl plus Regeln: erkennt Namen auch ohne Rollenwort</a:t>
+            </a:r>
+          </a:p>
+        </p:txBody>
+      </p:sp>
+      <p:sp>
+        <p:nvSpPr>
+          <p:cNvPr id="51" name="Hinweis Formular"/>
+          <p:cNvSpPr txBox="1"/>
+          <p:nvPr/>
+        </p:nvSpPr>
+        <p:spPr>
+          <a:xfrm>
+            <a:off x="7180000" y="3530000"/>
+            <a:ext cx="4300000" cy="640000"/>
+          </a:xfrm>
+          <a:prstGeom prst="rect">
+            <a:avLst/>
+          </a:prstGeom>
+          <a:noFill/>
+          <a:ln/>
+        </p:spPr>
+        <p:txBody>
+          <a:bodyPr wrap="square" lIns="0" tIns="0" rIns="0" bIns="0" rtlCol="0" anchor="t"/>
+          <a:lstStyle/>
+          <a:p>
+            <a:pPr indent="0" marL="0">
+              <a:spcAft>
+                <a:spcPts val="2"/>
+              </a:spcAft>
+              <a:buNone/>
+            </a:pPr>
+            <a:r>
+              <a:rPr lang="de-DE" sz="1300" dirty="0" b="1">
+                <a:solidFill>
+                  <a:schemeClr val="tx2"/>
+                </a:solidFill>
+              </a:rPr>
+              <a:t>Formular (Muster 13)</a:t>
+            </a:r>
+          </a:p>
+          <a:p>
+            <a:pPr indent="0" marL="0">
+              <a:buNone/>
+            </a:pPr>
+            <a:r>
+              <a:rPr lang="de-DE" sz="1200" dirty="0">
+                <a:solidFill>
+                  <a:schemeClr val="tx1"/>
+                </a:solidFill>
+              </a:rPr>
+              <a:t>Regelbasiert, Feld für Feld: Identifikatoren werden durch Marker ersetzt, Freitexte entfernt</a:t>
+            </a:r>
+          </a:p>
+        </p:txBody>
+      </p:sp>
+      <p:sp>
+        <p:nvSpPr>
+          <p:cNvPr id="52" name="Hinweis Stand"/>
+          <p:cNvSpPr txBox="1"/>
+          <p:nvPr/>
+        </p:nvSpPr>
+        <p:spPr>
+          <a:xfrm>
+            <a:off x="2880000" y="4180000"/>
+            <a:ext cx="8600000" cy="230000"/>
+          </a:xfrm>
+          <a:prstGeom prst="rect">
+            <a:avLst/>
+          </a:prstGeom>
+          <a:noFill/>
+          <a:ln/>
+        </p:spPr>
+        <p:txBody>
+          <a:bodyPr wrap="square" lIns="0" tIns="0" rIns="0" bIns="0" rtlCol="0" anchor="t"/>
+          <a:lstStyle/>
+          <a:p>
+            <a:pPr indent="0" marL="0">
+              <a:buNone/>
+            </a:pPr>
+            <a:r>
+              <a:rPr lang="de-DE" sz="1100" dirty="0" i="1">
+                <a:solidFill>
+                  <a:schemeClr val="accent5"/>
+                </a:solidFill>
+              </a:rPr>
+              <a:t>Cloud-Prototyp heute: Das NER-Modell läuft nur lokal, im Chat greifen dort die Regeln. Echte Daten nur über das Formular.</a:t>
+            </a:r>
           </a:p>
         </p:txBody>
       </p:sp>
@@ -19035,7 +19354,7 @@
                           <a:ea typeface="Calibri" pitchFamily="34" charset="-122"/>
                           <a:cs typeface="Calibri" pitchFamily="34" charset="-120"/>
                         </a:rPr>
-                        <a:t>Datenminimierung: Die Prüfung braucht keine Namen; Original bleibt nur im Protokoll</a:t>
+                        <a:t>Datenminimierung: Die Prüfung braucht keine Namen. Chat: NER-Modell plus Regeln, Formular: Regeln; Original nur im Protokoll</a:t>
                       </a:r>
                       <a:endParaRPr lang="en-US" sz="1300" dirty="0">
                         <a:latin typeface="Calibri" charset="0"/>
@@ -21456,7 +21775,7 @@
       </p:sp>
       <p:sp>
         <p:nvSpPr>
-          <p:cNvPr id="25" name="Slide Number Placeholder 0"/>
+          <p:cNvPr id="40" name="Slide Number Placeholder 0"/>
           <p:cNvSpPr>
             <a:spLocks noGrp="1"/>
           </p:cNvSpPr>
@@ -22625,7 +22944,7 @@
       </p:sp>
       <p:sp>
         <p:nvSpPr>
-          <p:cNvPr id="25" name="Slide Number Placeholder 0"/>
+          <p:cNvPr id="31" name="Slide Number Placeholder 0"/>
           <p:cNvSpPr>
             <a:spLocks noGrp="1"/>
           </p:cNvSpPr>
@@ -24992,7 +25311,7 @@
                           <a:ea typeface="Calibri" pitchFamily="34" charset="-122"/>
                           <a:cs typeface="Calibri" pitchFamily="34" charset="-120"/>
                         </a:rPr>
-                        <a:t>Patientendaten vor dem Modell ersetzt, Pseudonym statt Name</a:t>
+                        <a:t>Patientendaten vor dem Modell ersetzt, Pseudonym statt Name; Chat: NER-Modell plus Regeln, Formular: Regeln</a:t>
                       </a:r>
                       <a:endParaRPr lang="en-US" sz="1250" dirty="0">
                         <a:latin typeface="Calibri" charset="0"/>
@@ -27621,7 +27940,7 @@
       </p:sp>
       <p:sp>
         <p:nvSpPr>
-          <p:cNvPr id="25" name="Slide Number Placeholder 0"/>
+          <p:cNvPr id="31" name="Slide Number Placeholder 0"/>
           <p:cNvSpPr>
             <a:spLocks noGrp="1"/>
           </p:cNvSpPr>
@@ -30325,7 +30644,7 @@
       </p:sp>
       <p:sp>
         <p:nvSpPr>
-          <p:cNvPr id="25" name="Slide Number Placeholder 0"/>
+          <p:cNvPr id="34" name="Slide Number Placeholder 0"/>
           <p:cNvSpPr>
             <a:spLocks noGrp="1"/>
           </p:cNvSpPr>
@@ -30680,7 +30999,7 @@
                   <a:schemeClr val="tx1"/>
                 </a:solidFill>
               </a:rPr>
-              <a:t>Zusammenführung in n8n Cloud, Freitext-Redaktion als Regel-Code, fünf neue Regeln im Code</a:t>
+              <a:t>Zusammenführung in n8n Cloud, Chat-Redaktion als Regel-Code (NER-Modell nur lokal), fünf neue Regeln im Code</a:t>
             </a:r>
             <a:endParaRPr lang="en-US" sz="1400" dirty="0"/>
           </a:p>
@@ -30722,7 +31041,7 @@
                   <a:schemeClr val="tx1"/>
                 </a:solidFill>
               </a:rPr>
-              <a:t>unverändert, lauffähig</a:t>
+              <a:t>unverändert, lauffähig; der Chat nutzt dort den NER-Redaktionsdienst</a:t>
             </a:r>
             <a:endParaRPr lang="en-US" sz="1400" dirty="0"/>
           </a:p>
@@ -34803,7 +35122,7 @@
       </p:sp>
       <p:graphicFrame>
         <p:nvGraphicFramePr>
-          <p:cNvPr id="28" name="Table 0"/>
+          <p:cNvPr id="33" name="Table 0"/>
           <p:cNvGraphicFramePr>
             <a:graphicFrameLocks noGrp="1"/>
           </p:cNvGraphicFramePr>
@@ -35559,7 +35878,7 @@
       </p:sp>
       <p:sp>
         <p:nvSpPr>
-          <p:cNvPr id="25" name="Slide Number Placeholder 0"/>
+          <p:cNvPr id="34" name="Slide Number Placeholder 0"/>
           <p:cNvSpPr>
             <a:spLocks noGrp="1"/>
           </p:cNvSpPr>
@@ -37005,7 +37324,7 @@
       </p:sp>
       <p:sp>
         <p:nvSpPr>
-          <p:cNvPr id="25" name="Slide Number Placeholder 0"/>
+          <p:cNvPr id="41" name="Slide Number Placeholder 0"/>
           <p:cNvSpPr>
             <a:spLocks noGrp="1"/>
           </p:cNvSpPr>
@@ -38074,7 +38393,7 @@
       </p:sp>
       <p:sp>
         <p:nvSpPr>
-          <p:cNvPr id="25" name="Slide Number Placeholder 0"/>
+          <p:cNvPr id="33" name="Slide Number Placeholder 0"/>
           <p:cNvSpPr>
             <a:spLocks noGrp="1"/>
           </p:cNvSpPr>
@@ -40722,7 +41041,7 @@
       </p:sp>
       <p:sp>
         <p:nvSpPr>
-          <p:cNvPr id="25" name="Slide Number Placeholder 0"/>
+          <p:cNvPr id="34" name="Slide Number Placeholder 0"/>
           <p:cNvSpPr>
             <a:spLocks noGrp="1"/>
           </p:cNvSpPr>
@@ -45615,7 +45934,7 @@
       </p:sp>
       <p:sp>
         <p:nvSpPr>
-          <p:cNvPr id="25" name="Slide Number Placeholder 0"/>
+          <p:cNvPr id="49" name="Slide Number Placeholder 0"/>
           <p:cNvSpPr>
             <a:spLocks noGrp="1"/>
           </p:cNvSpPr>
@@ -46999,7 +47318,7 @@
       </p:sp>
       <p:sp>
         <p:nvSpPr>
-          <p:cNvPr id="25" name="Slide Number Placeholder 0"/>
+          <p:cNvPr id="43" name="Slide Number Placeholder 0"/>
           <p:cNvSpPr>
             <a:spLocks noGrp="1"/>
           </p:cNvSpPr>
@@ -47792,7 +48111,7 @@
       </p:sp>
       <p:graphicFrame>
         <p:nvGraphicFramePr>
-          <p:cNvPr id="8" name="Table 0"/>
+          <p:cNvPr id="26" name="Table 0"/>
           <p:cNvGraphicFramePr>
             <a:graphicFrameLocks noGrp="1"/>
           </p:cNvGraphicFramePr>
@@ -48889,7 +49208,7 @@
       </p:sp>
       <p:sp>
         <p:nvSpPr>
-          <p:cNvPr id="25" name="Slide Number Placeholder 0"/>
+          <p:cNvPr id="27" name="Slide Number Placeholder 0"/>
           <p:cNvSpPr>
             <a:spLocks noGrp="1"/>
           </p:cNvSpPr>
@@ -51114,7 +51433,7 @@
       </p:sp>
       <p:sp>
         <p:nvSpPr>
-          <p:cNvPr id="10" name="Text 6"/>
+          <p:cNvPr id="26" name="Text 6"/>
           <p:cNvSpPr txBox="1"/>
           <p:nvPr/>
         </p:nvSpPr>

</xml_diff>